<commit_message>
Regenerate Day3 PPT (Deep Blue Academic style)
</commit_message>
<xml_diff>
--- a/ppt/2026-05-12_genetics_day003.pptx
+++ b/ppt/2026-05-12_genetics_day003.pptx
@@ -1836,7 +1836,7 @@
     <p:bg>
       <p:bgPr>
         <a:solidFill>
-          <a:srgbClr val="2C5F2D"/>
+          <a:srgbClr val="003087"/>
         </a:solidFill>
       </p:bgPr>
     </p:bg>
@@ -1869,7 +1869,7 @@
             <a:avLst/>
           </a:prstGeom>
           <a:solidFill>
-            <a:srgbClr val="D4A843"/>
+            <a:srgbClr val="E67E22"/>
           </a:solidFill>
           <a:ln/>
         </p:spPr>
@@ -1940,7 +1940,7 @@
             <a:r>
               <a:rPr lang="en-US" sz="1800" dirty="0">
                 <a:solidFill>
-                  <a:srgbClr val="97BC62"/>
+                  <a:srgbClr val="666666"/>
                 </a:solidFill>
                 <a:latin typeface="Calibri" pitchFamily="34" charset="0"/>
                 <a:ea typeface="Calibri" pitchFamily="34" charset="-122"/>
@@ -2005,7 +2005,7 @@
     <p:bg>
       <p:bgPr>
         <a:solidFill>
-          <a:srgbClr val="FAF8F0"/>
+          <a:srgbClr val="F5F5F5"/>
         </a:solidFill>
       </p:bgPr>
     </p:bg>
@@ -2050,7 +2050,7 @@
             <a:r>
               <a:rPr lang="en-US" sz="2600" b="1" dirty="0">
                 <a:solidFill>
-                  <a:srgbClr val="2C5F2D"/>
+                  <a:srgbClr val="003087"/>
                 </a:solidFill>
                 <a:latin typeface="Georgia" pitchFamily="34" charset="0"/>
                 <a:ea typeface="Georgia" pitchFamily="34" charset="-122"/>
@@ -2077,7 +2077,7 @@
             <a:avLst/>
           </a:prstGeom>
           <a:solidFill>
-            <a:srgbClr val="D4A843"/>
+            <a:srgbClr val="E67E22"/>
           </a:solidFill>
           <a:ln/>
         </p:spPr>
@@ -2096,7 +2096,7 @@
     <p:bg>
       <p:bgPr>
         <a:solidFill>
-          <a:srgbClr val="FAF8F0"/>
+          <a:srgbClr val="F5F5F5"/>
         </a:solidFill>
       </p:bgPr>
     </p:bg>
@@ -2141,7 +2141,7 @@
             <a:r>
               <a:rPr lang="en-US" sz="2600" b="1" dirty="0">
                 <a:solidFill>
-                  <a:srgbClr val="2C5F2D"/>
+                  <a:srgbClr val="003087"/>
                 </a:solidFill>
                 <a:latin typeface="Georgia" pitchFamily="34" charset="0"/>
                 <a:ea typeface="Georgia" pitchFamily="34" charset="-122"/>
@@ -2168,7 +2168,7 @@
             <a:avLst/>
           </a:prstGeom>
           <a:solidFill>
-            <a:srgbClr val="D4A843"/>
+            <a:srgbClr val="E67E22"/>
           </a:solidFill>
           <a:ln/>
         </p:spPr>
@@ -2190,7 +2190,7 @@
             </a:avLst>
           </a:prstGeom>
           <a:solidFill>
-            <a:srgbClr val="2C5F2D"/>
+            <a:srgbClr val="003087"/>
           </a:solidFill>
           <a:ln/>
         </p:spPr>
@@ -2251,7 +2251,7 @@
             </a:avLst>
           </a:prstGeom>
           <a:solidFill>
-            <a:srgbClr val="2C5F2D"/>
+            <a:srgbClr val="003087"/>
           </a:solidFill>
           <a:ln/>
         </p:spPr>
@@ -2309,7 +2309,7 @@
     <p:bg>
       <p:bgPr>
         <a:solidFill>
-          <a:srgbClr val="2C5F2D"/>
+          <a:srgbClr val="003087"/>
         </a:solidFill>
       </p:bgPr>
     </p:bg>
@@ -2342,7 +2342,7 @@
             <a:avLst/>
           </a:prstGeom>
           <a:solidFill>
-            <a:srgbClr val="D4A843"/>
+            <a:srgbClr val="E67E22"/>
           </a:solidFill>
           <a:ln/>
         </p:spPr>
@@ -2413,7 +2413,7 @@
             <a:r>
               <a:rPr lang="en-US" sz="2000" dirty="0">
                 <a:solidFill>
-                  <a:srgbClr val="97BC62"/>
+                  <a:srgbClr val="666666"/>
                 </a:solidFill>
                 <a:latin typeface="Calibri" pitchFamily="34" charset="0"/>
                 <a:ea typeface="Calibri" pitchFamily="34" charset="-122"/>
@@ -2478,7 +2478,7 @@
     <p:bg>
       <p:bgPr>
         <a:solidFill>
-          <a:srgbClr val="FAF8F0"/>
+          <a:srgbClr val="F5F5F5"/>
         </a:solidFill>
       </p:bgPr>
     </p:bg>
@@ -2523,7 +2523,7 @@
             <a:r>
               <a:rPr lang="en-US" sz="2800" b="1" dirty="0">
                 <a:solidFill>
-                  <a:srgbClr val="2C5F2D"/>
+                  <a:srgbClr val="003087"/>
                 </a:solidFill>
                 <a:latin typeface="Georgia" pitchFamily="34" charset="0"/>
                 <a:ea typeface="Georgia" pitchFamily="34" charset="-122"/>
@@ -2550,7 +2550,7 @@
             <a:avLst/>
           </a:prstGeom>
           <a:solidFill>
-            <a:srgbClr val="D4A843"/>
+            <a:srgbClr val="E67E22"/>
           </a:solidFill>
           <a:ln/>
         </p:spPr>
@@ -2570,7 +2570,7 @@
             <a:avLst/>
           </a:prstGeom>
           <a:solidFill>
-            <a:srgbClr val="2C5F2D"/>
+            <a:srgbClr val="003087"/>
           </a:solidFill>
           <a:ln/>
         </p:spPr>
@@ -2668,7 +2668,7 @@
             <a:avLst/>
           </a:prstGeom>
           <a:solidFill>
-            <a:srgbClr val="2C5F2D"/>
+            <a:srgbClr val="003087"/>
           </a:solidFill>
           <a:ln/>
         </p:spPr>
@@ -2766,7 +2766,7 @@
             <a:avLst/>
           </a:prstGeom>
           <a:solidFill>
-            <a:srgbClr val="2C5F2D"/>
+            <a:srgbClr val="003087"/>
           </a:solidFill>
           <a:ln/>
         </p:spPr>
@@ -2864,7 +2864,7 @@
             <a:avLst/>
           </a:prstGeom>
           <a:solidFill>
-            <a:srgbClr val="2C5F2D"/>
+            <a:srgbClr val="003087"/>
           </a:solidFill>
           <a:ln/>
         </p:spPr>
@@ -2962,7 +2962,7 @@
             <a:avLst/>
           </a:prstGeom>
           <a:solidFill>
-            <a:srgbClr val="2C5F2D"/>
+            <a:srgbClr val="003087"/>
           </a:solidFill>
           <a:ln/>
         </p:spPr>
@@ -3060,7 +3060,7 @@
             <a:avLst/>
           </a:prstGeom>
           <a:solidFill>
-            <a:srgbClr val="2C5F2D"/>
+            <a:srgbClr val="003087"/>
           </a:solidFill>
           <a:ln/>
         </p:spPr>
@@ -3158,7 +3158,7 @@
             <a:avLst/>
           </a:prstGeom>
           <a:solidFill>
-            <a:srgbClr val="2C5F2D"/>
+            <a:srgbClr val="003087"/>
           </a:solidFill>
           <a:ln/>
         </p:spPr>
@@ -3256,7 +3256,7 @@
             <a:avLst/>
           </a:prstGeom>
           <a:solidFill>
-            <a:srgbClr val="2C5F2D"/>
+            <a:srgbClr val="003087"/>
           </a:solidFill>
           <a:ln/>
         </p:spPr>
@@ -3353,7 +3353,7 @@
     <p:bg>
       <p:bgPr>
         <a:solidFill>
-          <a:srgbClr val="FAF8F0"/>
+          <a:srgbClr val="F5F5F5"/>
         </a:solidFill>
       </p:bgPr>
     </p:bg>
@@ -3398,7 +3398,7 @@
             <a:r>
               <a:rPr lang="en-US" sz="2600" b="1" dirty="0">
                 <a:solidFill>
-                  <a:srgbClr val="2C5F2D"/>
+                  <a:srgbClr val="003087"/>
                 </a:solidFill>
                 <a:latin typeface="Georgia" pitchFamily="34" charset="0"/>
                 <a:ea typeface="Georgia" pitchFamily="34" charset="-122"/>
@@ -3425,7 +3425,7 @@
             <a:avLst/>
           </a:prstGeom>
           <a:solidFill>
-            <a:srgbClr val="D4A843"/>
+            <a:srgbClr val="E67E22"/>
           </a:solidFill>
           <a:ln/>
         </p:spPr>
@@ -3444,7 +3444,7 @@
     <p:bg>
       <p:bgPr>
         <a:solidFill>
-          <a:srgbClr val="FAF8F0"/>
+          <a:srgbClr val="F5F5F5"/>
         </a:solidFill>
       </p:bgPr>
     </p:bg>
@@ -3489,7 +3489,7 @@
             <a:r>
               <a:rPr lang="en-US" sz="2600" b="1" dirty="0">
                 <a:solidFill>
-                  <a:srgbClr val="2C5F2D"/>
+                  <a:srgbClr val="003087"/>
                 </a:solidFill>
                 <a:latin typeface="Georgia" pitchFamily="34" charset="0"/>
                 <a:ea typeface="Georgia" pitchFamily="34" charset="-122"/>
@@ -3516,7 +3516,7 @@
             <a:avLst/>
           </a:prstGeom>
           <a:solidFill>
-            <a:srgbClr val="D4A843"/>
+            <a:srgbClr val="E67E22"/>
           </a:solidFill>
           <a:ln/>
         </p:spPr>
@@ -3538,7 +3538,7 @@
             </a:avLst>
           </a:prstGeom>
           <a:solidFill>
-            <a:srgbClr val="D5D0C4"/>
+            <a:srgbClr val="DDDDDD"/>
           </a:solidFill>
           <a:ln/>
         </p:spPr>
@@ -3580,7 +3580,7 @@
             <a:avLst/>
           </a:prstGeom>
           <a:solidFill>
-            <a:srgbClr val="2C5F2D"/>
+            <a:srgbClr val="003087"/>
           </a:solidFill>
           <a:ln/>
         </p:spPr>
@@ -3600,7 +3600,7 @@
             <a:avLst/>
           </a:prstGeom>
           <a:solidFill>
-            <a:srgbClr val="2C5F2D"/>
+            <a:srgbClr val="003087"/>
           </a:solidFill>
           <a:ln/>
         </p:spPr>
@@ -3700,7 +3700,7 @@
             </a:avLst>
           </a:prstGeom>
           <a:solidFill>
-            <a:srgbClr val="D5D0C4"/>
+            <a:srgbClr val="DDDDDD"/>
           </a:solidFill>
           <a:ln/>
         </p:spPr>
@@ -3742,7 +3742,7 @@
             <a:avLst/>
           </a:prstGeom>
           <a:solidFill>
-            <a:srgbClr val="2C5F2D"/>
+            <a:srgbClr val="003087"/>
           </a:solidFill>
           <a:ln/>
         </p:spPr>
@@ -3762,7 +3762,7 @@
             <a:avLst/>
           </a:prstGeom>
           <a:solidFill>
-            <a:srgbClr val="2C5F2D"/>
+            <a:srgbClr val="003087"/>
           </a:solidFill>
           <a:ln/>
         </p:spPr>
@@ -3862,7 +3862,7 @@
             </a:avLst>
           </a:prstGeom>
           <a:solidFill>
-            <a:srgbClr val="D5D0C4"/>
+            <a:srgbClr val="DDDDDD"/>
           </a:solidFill>
           <a:ln/>
         </p:spPr>
@@ -3904,7 +3904,7 @@
             <a:avLst/>
           </a:prstGeom>
           <a:solidFill>
-            <a:srgbClr val="2C5F2D"/>
+            <a:srgbClr val="003087"/>
           </a:solidFill>
           <a:ln/>
         </p:spPr>
@@ -3924,7 +3924,7 @@
             <a:avLst/>
           </a:prstGeom>
           <a:solidFill>
-            <a:srgbClr val="2C5F2D"/>
+            <a:srgbClr val="003087"/>
           </a:solidFill>
           <a:ln/>
         </p:spPr>
@@ -4024,7 +4024,7 @@
             </a:avLst>
           </a:prstGeom>
           <a:solidFill>
-            <a:srgbClr val="D5D0C4"/>
+            <a:srgbClr val="DDDDDD"/>
           </a:solidFill>
           <a:ln/>
         </p:spPr>
@@ -4066,7 +4066,7 @@
             <a:avLst/>
           </a:prstGeom>
           <a:solidFill>
-            <a:srgbClr val="2C5F2D"/>
+            <a:srgbClr val="003087"/>
           </a:solidFill>
           <a:ln/>
         </p:spPr>
@@ -4086,7 +4086,7 @@
             <a:avLst/>
           </a:prstGeom>
           <a:solidFill>
-            <a:srgbClr val="2C5F2D"/>
+            <a:srgbClr val="003087"/>
           </a:solidFill>
           <a:ln/>
         </p:spPr>
@@ -4186,7 +4186,7 @@
             </a:avLst>
           </a:prstGeom>
           <a:solidFill>
-            <a:srgbClr val="2C5F2D"/>
+            <a:srgbClr val="003087"/>
           </a:solidFill>
           <a:ln/>
         </p:spPr>
@@ -4247,7 +4247,7 @@
             </a:avLst>
           </a:prstGeom>
           <a:solidFill>
-            <a:srgbClr val="2C5F2D"/>
+            <a:srgbClr val="003087"/>
           </a:solidFill>
           <a:ln/>
         </p:spPr>
@@ -4305,7 +4305,7 @@
     <p:bg>
       <p:bgPr>
         <a:solidFill>
-          <a:srgbClr val="FAF8F0"/>
+          <a:srgbClr val="F5F5F5"/>
         </a:solidFill>
       </p:bgPr>
     </p:bg>
@@ -4350,7 +4350,7 @@
             <a:r>
               <a:rPr lang="en-US" sz="2600" b="1" dirty="0">
                 <a:solidFill>
-                  <a:srgbClr val="2C5F2D"/>
+                  <a:srgbClr val="003087"/>
                 </a:solidFill>
                 <a:latin typeface="Georgia" pitchFamily="34" charset="0"/>
                 <a:ea typeface="Georgia" pitchFamily="34" charset="-122"/>
@@ -4377,7 +4377,7 @@
             <a:avLst/>
           </a:prstGeom>
           <a:solidFill>
-            <a:srgbClr val="D4A843"/>
+            <a:srgbClr val="E67E22"/>
           </a:solidFill>
           <a:ln/>
         </p:spPr>
@@ -4399,7 +4399,7 @@
             </a:avLst>
           </a:prstGeom>
           <a:solidFill>
-            <a:srgbClr val="2C5F2D"/>
+            <a:srgbClr val="003087"/>
           </a:solidFill>
           <a:ln/>
         </p:spPr>
@@ -4460,7 +4460,7 @@
             </a:avLst>
           </a:prstGeom>
           <a:solidFill>
-            <a:srgbClr val="2C5F2D"/>
+            <a:srgbClr val="003087"/>
           </a:solidFill>
           <a:ln/>
         </p:spPr>
@@ -4518,7 +4518,7 @@
     <p:bg>
       <p:bgPr>
         <a:solidFill>
-          <a:srgbClr val="FAF8F0"/>
+          <a:srgbClr val="F5F5F5"/>
         </a:solidFill>
       </p:bgPr>
     </p:bg>
@@ -4563,7 +4563,7 @@
             <a:r>
               <a:rPr lang="en-US" sz="2600" b="1" dirty="0">
                 <a:solidFill>
-                  <a:srgbClr val="2C5F2D"/>
+                  <a:srgbClr val="003087"/>
                 </a:solidFill>
                 <a:latin typeface="Georgia" pitchFamily="34" charset="0"/>
                 <a:ea typeface="Georgia" pitchFamily="34" charset="-122"/>
@@ -4590,7 +4590,7 @@
             <a:avLst/>
           </a:prstGeom>
           <a:solidFill>
-            <a:srgbClr val="D4A843"/>
+            <a:srgbClr val="E67E22"/>
           </a:solidFill>
           <a:ln/>
         </p:spPr>
@@ -4612,7 +4612,7 @@
             </a:avLst>
           </a:prstGeom>
           <a:solidFill>
-            <a:srgbClr val="2C5F2D"/>
+            <a:srgbClr val="003087"/>
           </a:solidFill>
           <a:ln/>
         </p:spPr>
@@ -4673,7 +4673,7 @@
             </a:avLst>
           </a:prstGeom>
           <a:solidFill>
-            <a:srgbClr val="2C5F2D"/>
+            <a:srgbClr val="003087"/>
           </a:solidFill>
           <a:ln/>
         </p:spPr>
@@ -4731,7 +4731,7 @@
     <p:bg>
       <p:bgPr>
         <a:solidFill>
-          <a:srgbClr val="FAF8F0"/>
+          <a:srgbClr val="F5F5F5"/>
         </a:solidFill>
       </p:bgPr>
     </p:bg>
@@ -4776,7 +4776,7 @@
             <a:r>
               <a:rPr lang="en-US" sz="2600" b="1" dirty="0">
                 <a:solidFill>
-                  <a:srgbClr val="2C5F2D"/>
+                  <a:srgbClr val="003087"/>
                 </a:solidFill>
                 <a:latin typeface="Georgia" pitchFamily="34" charset="0"/>
                 <a:ea typeface="Georgia" pitchFamily="34" charset="-122"/>
@@ -4803,7 +4803,7 @@
             <a:avLst/>
           </a:prstGeom>
           <a:solidFill>
-            <a:srgbClr val="D4A843"/>
+            <a:srgbClr val="E67E22"/>
           </a:solidFill>
           <a:ln/>
         </p:spPr>
@@ -4825,7 +4825,7 @@
             </a:avLst>
           </a:prstGeom>
           <a:solidFill>
-            <a:srgbClr val="D5D0C4"/>
+            <a:srgbClr val="DDDDDD"/>
           </a:solidFill>
           <a:ln/>
         </p:spPr>
@@ -4867,7 +4867,7 @@
             <a:avLst/>
           </a:prstGeom>
           <a:solidFill>
-            <a:srgbClr val="2C5F2D"/>
+            <a:srgbClr val="003087"/>
           </a:solidFill>
           <a:ln/>
         </p:spPr>
@@ -4887,7 +4887,7 @@
             <a:avLst/>
           </a:prstGeom>
           <a:solidFill>
-            <a:srgbClr val="2C5F2D"/>
+            <a:srgbClr val="003087"/>
           </a:solidFill>
           <a:ln/>
         </p:spPr>
@@ -4987,7 +4987,7 @@
             </a:avLst>
           </a:prstGeom>
           <a:solidFill>
-            <a:srgbClr val="D5D0C4"/>
+            <a:srgbClr val="DDDDDD"/>
           </a:solidFill>
           <a:ln/>
         </p:spPr>
@@ -5029,7 +5029,7 @@
             <a:avLst/>
           </a:prstGeom>
           <a:solidFill>
-            <a:srgbClr val="2C5F2D"/>
+            <a:srgbClr val="003087"/>
           </a:solidFill>
           <a:ln/>
         </p:spPr>
@@ -5049,7 +5049,7 @@
             <a:avLst/>
           </a:prstGeom>
           <a:solidFill>
-            <a:srgbClr val="2C5F2D"/>
+            <a:srgbClr val="003087"/>
           </a:solidFill>
           <a:ln/>
         </p:spPr>
@@ -5149,7 +5149,7 @@
             </a:avLst>
           </a:prstGeom>
           <a:solidFill>
-            <a:srgbClr val="D5D0C4"/>
+            <a:srgbClr val="DDDDDD"/>
           </a:solidFill>
           <a:ln/>
         </p:spPr>
@@ -5191,7 +5191,7 @@
             <a:avLst/>
           </a:prstGeom>
           <a:solidFill>
-            <a:srgbClr val="2C5F2D"/>
+            <a:srgbClr val="003087"/>
           </a:solidFill>
           <a:ln/>
         </p:spPr>
@@ -5211,7 +5211,7 @@
             <a:avLst/>
           </a:prstGeom>
           <a:solidFill>
-            <a:srgbClr val="2C5F2D"/>
+            <a:srgbClr val="003087"/>
           </a:solidFill>
           <a:ln/>
         </p:spPr>
@@ -5311,7 +5311,7 @@
             </a:avLst>
           </a:prstGeom>
           <a:solidFill>
-            <a:srgbClr val="D5D0C4"/>
+            <a:srgbClr val="DDDDDD"/>
           </a:solidFill>
           <a:ln/>
         </p:spPr>
@@ -5353,7 +5353,7 @@
             <a:avLst/>
           </a:prstGeom>
           <a:solidFill>
-            <a:srgbClr val="2C5F2D"/>
+            <a:srgbClr val="003087"/>
           </a:solidFill>
           <a:ln/>
         </p:spPr>
@@ -5373,7 +5373,7 @@
             <a:avLst/>
           </a:prstGeom>
           <a:solidFill>
-            <a:srgbClr val="2C5F2D"/>
+            <a:srgbClr val="003087"/>
           </a:solidFill>
           <a:ln/>
         </p:spPr>
@@ -5473,7 +5473,7 @@
             </a:avLst>
           </a:prstGeom>
           <a:solidFill>
-            <a:srgbClr val="2C5F2D"/>
+            <a:srgbClr val="003087"/>
           </a:solidFill>
           <a:ln/>
         </p:spPr>
@@ -5531,7 +5531,7 @@
     <p:bg>
       <p:bgPr>
         <a:solidFill>
-          <a:srgbClr val="FAF8F0"/>
+          <a:srgbClr val="F5F5F5"/>
         </a:solidFill>
       </p:bgPr>
     </p:bg>
@@ -5576,7 +5576,7 @@
             <a:r>
               <a:rPr lang="en-US" sz="2600" b="1" dirty="0">
                 <a:solidFill>
-                  <a:srgbClr val="2C5F2D"/>
+                  <a:srgbClr val="003087"/>
                 </a:solidFill>
                 <a:latin typeface="Georgia" pitchFamily="34" charset="0"/>
                 <a:ea typeface="Georgia" pitchFamily="34" charset="-122"/>
@@ -5603,7 +5603,7 @@
             <a:avLst/>
           </a:prstGeom>
           <a:solidFill>
-            <a:srgbClr val="D4A843"/>
+            <a:srgbClr val="E67E22"/>
           </a:solidFill>
           <a:ln/>
         </p:spPr>
@@ -5625,7 +5625,7 @@
             </a:avLst>
           </a:prstGeom>
           <a:solidFill>
-            <a:srgbClr val="D5D0C4"/>
+            <a:srgbClr val="DDDDDD"/>
           </a:solidFill>
           <a:ln/>
         </p:spPr>
@@ -5667,7 +5667,7 @@
             <a:avLst/>
           </a:prstGeom>
           <a:solidFill>
-            <a:srgbClr val="2C5F2D"/>
+            <a:srgbClr val="003087"/>
           </a:solidFill>
           <a:ln/>
         </p:spPr>
@@ -5687,7 +5687,7 @@
             <a:avLst/>
           </a:prstGeom>
           <a:solidFill>
-            <a:srgbClr val="2C5F2D"/>
+            <a:srgbClr val="003087"/>
           </a:solidFill>
           <a:ln/>
         </p:spPr>
@@ -5787,7 +5787,7 @@
             </a:avLst>
           </a:prstGeom>
           <a:solidFill>
-            <a:srgbClr val="D5D0C4"/>
+            <a:srgbClr val="DDDDDD"/>
           </a:solidFill>
           <a:ln/>
         </p:spPr>
@@ -5829,7 +5829,7 @@
             <a:avLst/>
           </a:prstGeom>
           <a:solidFill>
-            <a:srgbClr val="2C5F2D"/>
+            <a:srgbClr val="003087"/>
           </a:solidFill>
           <a:ln/>
         </p:spPr>
@@ -5849,7 +5849,7 @@
             <a:avLst/>
           </a:prstGeom>
           <a:solidFill>
-            <a:srgbClr val="2C5F2D"/>
+            <a:srgbClr val="003087"/>
           </a:solidFill>
           <a:ln/>
         </p:spPr>
@@ -5949,7 +5949,7 @@
             </a:avLst>
           </a:prstGeom>
           <a:solidFill>
-            <a:srgbClr val="D5D0C4"/>
+            <a:srgbClr val="DDDDDD"/>
           </a:solidFill>
           <a:ln/>
         </p:spPr>
@@ -5991,7 +5991,7 @@
             <a:avLst/>
           </a:prstGeom>
           <a:solidFill>
-            <a:srgbClr val="2C5F2D"/>
+            <a:srgbClr val="003087"/>
           </a:solidFill>
           <a:ln/>
         </p:spPr>
@@ -6011,7 +6011,7 @@
             <a:avLst/>
           </a:prstGeom>
           <a:solidFill>
-            <a:srgbClr val="2C5F2D"/>
+            <a:srgbClr val="003087"/>
           </a:solidFill>
           <a:ln/>
         </p:spPr>
@@ -6111,7 +6111,7 @@
             </a:avLst>
           </a:prstGeom>
           <a:solidFill>
-            <a:srgbClr val="D5D0C4"/>
+            <a:srgbClr val="DDDDDD"/>
           </a:solidFill>
           <a:ln/>
         </p:spPr>
@@ -6153,7 +6153,7 @@
             <a:avLst/>
           </a:prstGeom>
           <a:solidFill>
-            <a:srgbClr val="2C5F2D"/>
+            <a:srgbClr val="003087"/>
           </a:solidFill>
           <a:ln/>
         </p:spPr>
@@ -6173,7 +6173,7 @@
             <a:avLst/>
           </a:prstGeom>
           <a:solidFill>
-            <a:srgbClr val="2C5F2D"/>
+            <a:srgbClr val="003087"/>
           </a:solidFill>
           <a:ln/>
         </p:spPr>
@@ -6273,7 +6273,7 @@
             </a:avLst>
           </a:prstGeom>
           <a:solidFill>
-            <a:srgbClr val="2C5F2D"/>
+            <a:srgbClr val="003087"/>
           </a:solidFill>
           <a:ln/>
         </p:spPr>
@@ -6334,7 +6334,7 @@
             </a:avLst>
           </a:prstGeom>
           <a:solidFill>
-            <a:srgbClr val="2C5F2D"/>
+            <a:srgbClr val="003087"/>
           </a:solidFill>
           <a:ln/>
         </p:spPr>
@@ -6392,7 +6392,7 @@
     <p:bg>
       <p:bgPr>
         <a:solidFill>
-          <a:srgbClr val="FAF8F0"/>
+          <a:srgbClr val="F5F5F5"/>
         </a:solidFill>
       </p:bgPr>
     </p:bg>
@@ -6437,7 +6437,7 @@
             <a:r>
               <a:rPr lang="en-US" sz="2600" b="1" dirty="0">
                 <a:solidFill>
-                  <a:srgbClr val="2C5F2D"/>
+                  <a:srgbClr val="003087"/>
                 </a:solidFill>
                 <a:latin typeface="Georgia" pitchFamily="34" charset="0"/>
                 <a:ea typeface="Georgia" pitchFamily="34" charset="-122"/>
@@ -6464,7 +6464,7 @@
             <a:avLst/>
           </a:prstGeom>
           <a:solidFill>
-            <a:srgbClr val="D4A843"/>
+            <a:srgbClr val="E67E22"/>
           </a:solidFill>
           <a:ln/>
         </p:spPr>

</xml_diff>

<commit_message>
Regenerate Day3 PPT (Forest & Moss style)
</commit_message>
<xml_diff>
--- a/ppt/2026-05-12_genetics_day003.pptx
+++ b/ppt/2026-05-12_genetics_day003.pptx
@@ -1836,7 +1836,7 @@
     <p:bg>
       <p:bgPr>
         <a:solidFill>
-          <a:srgbClr val="003087"/>
+          <a:srgbClr val="2D5A27"/>
         </a:solidFill>
       </p:bgPr>
     </p:bg>
@@ -1869,7 +1869,7 @@
             <a:avLst/>
           </a:prstGeom>
           <a:solidFill>
-            <a:srgbClr val="E67E22"/>
+            <a:srgbClr val="D4A574"/>
           </a:solidFill>
           <a:ln/>
         </p:spPr>
@@ -1901,7 +1901,7 @@
             <a:r>
               <a:rPr lang="en-US" sz="4400" b="1" dirty="0">
                 <a:solidFill>
-                  <a:srgbClr val="FFFFFF"/>
+                  <a:srgbClr val="FFFEF9"/>
                 </a:solidFill>
                 <a:latin typeface="Georgia" pitchFamily="34" charset="0"/>
                 <a:ea typeface="Georgia" pitchFamily="34" charset="-122"/>
@@ -1940,7 +1940,7 @@
             <a:r>
               <a:rPr lang="en-US" sz="1800" dirty="0">
                 <a:solidFill>
-                  <a:srgbClr val="666666"/>
+                  <a:srgbClr val="6B6B6B"/>
                 </a:solidFill>
                 <a:latin typeface="Calibri" pitchFamily="34" charset="0"/>
                 <a:ea typeface="Calibri" pitchFamily="34" charset="-122"/>
@@ -1979,7 +1979,7 @@
             <a:r>
               <a:rPr lang="en-US" sz="1400" dirty="0">
                 <a:solidFill>
-                  <a:srgbClr val="FFFFFF"/>
+                  <a:srgbClr val="FFFEF9"/>
                 </a:solidFill>
                 <a:latin typeface="Calibri" pitchFamily="34" charset="0"/>
                 <a:ea typeface="Calibri" pitchFamily="34" charset="-122"/>
@@ -2005,7 +2005,7 @@
     <p:bg>
       <p:bgPr>
         <a:solidFill>
-          <a:srgbClr val="F5F5F5"/>
+          <a:srgbClr val="FDF8F3"/>
         </a:solidFill>
       </p:bgPr>
     </p:bg>
@@ -2050,7 +2050,7 @@
             <a:r>
               <a:rPr lang="en-US" sz="2600" b="1" dirty="0">
                 <a:solidFill>
-                  <a:srgbClr val="003087"/>
+                  <a:srgbClr val="2D5A27"/>
                 </a:solidFill>
                 <a:latin typeface="Georgia" pitchFamily="34" charset="0"/>
                 <a:ea typeface="Georgia" pitchFamily="34" charset="-122"/>
@@ -2077,7 +2077,7 @@
             <a:avLst/>
           </a:prstGeom>
           <a:solidFill>
-            <a:srgbClr val="E67E22"/>
+            <a:srgbClr val="D4A574"/>
           </a:solidFill>
           <a:ln/>
         </p:spPr>
@@ -2096,7 +2096,7 @@
     <p:bg>
       <p:bgPr>
         <a:solidFill>
-          <a:srgbClr val="F5F5F5"/>
+          <a:srgbClr val="FDF8F3"/>
         </a:solidFill>
       </p:bgPr>
     </p:bg>
@@ -2141,7 +2141,7 @@
             <a:r>
               <a:rPr lang="en-US" sz="2600" b="1" dirty="0">
                 <a:solidFill>
-                  <a:srgbClr val="003087"/>
+                  <a:srgbClr val="2D5A27"/>
                 </a:solidFill>
                 <a:latin typeface="Georgia" pitchFamily="34" charset="0"/>
                 <a:ea typeface="Georgia" pitchFamily="34" charset="-122"/>
@@ -2168,7 +2168,7 @@
             <a:avLst/>
           </a:prstGeom>
           <a:solidFill>
-            <a:srgbClr val="E67E22"/>
+            <a:srgbClr val="D4A574"/>
           </a:solidFill>
           <a:ln/>
         </p:spPr>
@@ -2190,7 +2190,7 @@
             </a:avLst>
           </a:prstGeom>
           <a:solidFill>
-            <a:srgbClr val="003087"/>
+            <a:srgbClr val="2D5A27"/>
           </a:solidFill>
           <a:ln/>
         </p:spPr>
@@ -2222,7 +2222,7 @@
             <a:r>
               <a:rPr lang="en-US" sz="1300" i="1" dirty="0">
                 <a:solidFill>
-                  <a:srgbClr val="FFFFFF"/>
+                  <a:srgbClr val="FFFEF9"/>
                 </a:solidFill>
                 <a:latin typeface="Calibri" pitchFamily="34" charset="0"/>
                 <a:ea typeface="Calibri" pitchFamily="34" charset="-122"/>
@@ -2251,7 +2251,7 @@
             </a:avLst>
           </a:prstGeom>
           <a:solidFill>
-            <a:srgbClr val="003087"/>
+            <a:srgbClr val="2D5A27"/>
           </a:solidFill>
           <a:ln/>
         </p:spPr>
@@ -2283,7 +2283,7 @@
             <a:r>
               <a:rPr lang="en-US" sz="1300" i="1" dirty="0">
                 <a:solidFill>
-                  <a:srgbClr val="FFFFFF"/>
+                  <a:srgbClr val="FFFEF9"/>
                 </a:solidFill>
                 <a:latin typeface="Calibri" pitchFamily="34" charset="0"/>
                 <a:ea typeface="Calibri" pitchFamily="34" charset="-122"/>
@@ -2309,7 +2309,7 @@
     <p:bg>
       <p:bgPr>
         <a:solidFill>
-          <a:srgbClr val="003087"/>
+          <a:srgbClr val="2D5A27"/>
         </a:solidFill>
       </p:bgPr>
     </p:bg>
@@ -2342,7 +2342,7 @@
             <a:avLst/>
           </a:prstGeom>
           <a:solidFill>
-            <a:srgbClr val="E67E22"/>
+            <a:srgbClr val="D4A574"/>
           </a:solidFill>
           <a:ln/>
         </p:spPr>
@@ -2374,7 +2374,7 @@
             <a:r>
               <a:rPr lang="en-US" sz="4800" b="1" dirty="0">
                 <a:solidFill>
-                  <a:srgbClr val="FFFFFF"/>
+                  <a:srgbClr val="FFFEF9"/>
                 </a:solidFill>
                 <a:latin typeface="Georgia" pitchFamily="34" charset="0"/>
                 <a:ea typeface="Georgia" pitchFamily="34" charset="-122"/>
@@ -2413,7 +2413,7 @@
             <a:r>
               <a:rPr lang="en-US" sz="2000" dirty="0">
                 <a:solidFill>
-                  <a:srgbClr val="666666"/>
+                  <a:srgbClr val="6B6B6B"/>
                 </a:solidFill>
                 <a:latin typeface="Calibri" pitchFamily="34" charset="0"/>
                 <a:ea typeface="Calibri" pitchFamily="34" charset="-122"/>
@@ -2452,7 +2452,7 @@
             <a:r>
               <a:rPr lang="en-US" sz="1200" dirty="0">
                 <a:solidFill>
-                  <a:srgbClr val="FFFFFF"/>
+                  <a:srgbClr val="FFFEF9"/>
                 </a:solidFill>
                 <a:latin typeface="Calibri" pitchFamily="34" charset="0"/>
                 <a:ea typeface="Calibri" pitchFamily="34" charset="-122"/>
@@ -2478,7 +2478,7 @@
     <p:bg>
       <p:bgPr>
         <a:solidFill>
-          <a:srgbClr val="F5F5F5"/>
+          <a:srgbClr val="FDF8F3"/>
         </a:solidFill>
       </p:bgPr>
     </p:bg>
@@ -2523,7 +2523,7 @@
             <a:r>
               <a:rPr lang="en-US" sz="2800" b="1" dirty="0">
                 <a:solidFill>
-                  <a:srgbClr val="003087"/>
+                  <a:srgbClr val="2D5A27"/>
                 </a:solidFill>
                 <a:latin typeface="Georgia" pitchFamily="34" charset="0"/>
                 <a:ea typeface="Georgia" pitchFamily="34" charset="-122"/>
@@ -2550,7 +2550,7 @@
             <a:avLst/>
           </a:prstGeom>
           <a:solidFill>
-            <a:srgbClr val="E67E22"/>
+            <a:srgbClr val="D4A574"/>
           </a:solidFill>
           <a:ln/>
         </p:spPr>
@@ -2563,14 +2563,14 @@
         </p:nvSpPr>
         <p:spPr>
           <a:xfrm>
-            <a:off x="594360" y="1188720"/>
-            <a:ext cx="365760" cy="365760"/>
+            <a:off x="576072" y="1170432"/>
+            <a:ext cx="402336" cy="402336"/>
           </a:xfrm>
           <a:prstGeom prst="ellipse">
             <a:avLst/>
           </a:prstGeom>
           <a:solidFill>
-            <a:srgbClr val="003087"/>
+            <a:srgbClr val="2D5A27"/>
           </a:solidFill>
           <a:ln/>
         </p:spPr>
@@ -2583,8 +2583,8 @@
         </p:nvSpPr>
         <p:spPr>
           <a:xfrm>
-            <a:off x="594360" y="1188720"/>
-            <a:ext cx="365760" cy="365760"/>
+            <a:off x="576072" y="1170432"/>
+            <a:ext cx="402336" cy="402336"/>
           </a:xfrm>
           <a:prstGeom prst="rect">
             <a:avLst/>
@@ -2600,9 +2600,9 @@
               <a:buNone/>
             </a:pPr>
             <a:r>
-              <a:rPr lang="en-US" sz="1100" b="1" dirty="0">
+              <a:rPr lang="en-US" sz="1200" b="1" dirty="0">
                 <a:solidFill>
-                  <a:srgbClr val="FFFFFF"/>
+                  <a:srgbClr val="FFFEF9"/>
                 </a:solidFill>
                 <a:latin typeface="Calibri" pitchFamily="34" charset="0"/>
                 <a:ea typeface="Calibri" pitchFamily="34" charset="-122"/>
@@ -2610,7 +2610,7 @@
               </a:rPr>
               <a:t>1</a:t>
             </a:r>
-            <a:endParaRPr lang="en-US" sz="1100" dirty="0"/>
+            <a:endParaRPr lang="en-US" sz="1200" dirty="0"/>
           </a:p>
         </p:txBody>
       </p:sp>
@@ -2641,7 +2641,7 @@
             <a:r>
               <a:rPr lang="en-US" sz="1600" dirty="0">
                 <a:solidFill>
-                  <a:srgbClr val="333333"/>
+                  <a:srgbClr val="3D3D3D"/>
                 </a:solidFill>
                 <a:latin typeface="Calibri" pitchFamily="34" charset="0"/>
                 <a:ea typeface="Calibri" pitchFamily="34" charset="-122"/>
@@ -2661,14 +2661,14 @@
         </p:nvSpPr>
         <p:spPr>
           <a:xfrm>
-            <a:off x="594360" y="1645920"/>
-            <a:ext cx="365760" cy="365760"/>
+            <a:off x="576072" y="1627632"/>
+            <a:ext cx="402336" cy="402336"/>
           </a:xfrm>
           <a:prstGeom prst="ellipse">
             <a:avLst/>
           </a:prstGeom>
           <a:solidFill>
-            <a:srgbClr val="003087"/>
+            <a:srgbClr val="2D5A27"/>
           </a:solidFill>
           <a:ln/>
         </p:spPr>
@@ -2681,8 +2681,8 @@
         </p:nvSpPr>
         <p:spPr>
           <a:xfrm>
-            <a:off x="594360" y="1645920"/>
-            <a:ext cx="365760" cy="365760"/>
+            <a:off x="576072" y="1627632"/>
+            <a:ext cx="402336" cy="402336"/>
           </a:xfrm>
           <a:prstGeom prst="rect">
             <a:avLst/>
@@ -2698,9 +2698,9 @@
               <a:buNone/>
             </a:pPr>
             <a:r>
-              <a:rPr lang="en-US" sz="1100" b="1" dirty="0">
+              <a:rPr lang="en-US" sz="1200" b="1" dirty="0">
                 <a:solidFill>
-                  <a:srgbClr val="FFFFFF"/>
+                  <a:srgbClr val="FFFEF9"/>
                 </a:solidFill>
                 <a:latin typeface="Calibri" pitchFamily="34" charset="0"/>
                 <a:ea typeface="Calibri" pitchFamily="34" charset="-122"/>
@@ -2708,7 +2708,7 @@
               </a:rPr>
               <a:t>2</a:t>
             </a:r>
-            <a:endParaRPr lang="en-US" sz="1100" dirty="0"/>
+            <a:endParaRPr lang="en-US" sz="1200" dirty="0"/>
           </a:p>
         </p:txBody>
       </p:sp>
@@ -2739,7 +2739,7 @@
             <a:r>
               <a:rPr lang="en-US" sz="1600" dirty="0">
                 <a:solidFill>
-                  <a:srgbClr val="333333"/>
+                  <a:srgbClr val="3D3D3D"/>
                 </a:solidFill>
                 <a:latin typeface="Calibri" pitchFamily="34" charset="0"/>
                 <a:ea typeface="Calibri" pitchFamily="34" charset="-122"/>
@@ -2759,14 +2759,14 @@
         </p:nvSpPr>
         <p:spPr>
           <a:xfrm>
-            <a:off x="594360" y="2103120"/>
-            <a:ext cx="365760" cy="365760"/>
+            <a:off x="576072" y="2084832"/>
+            <a:ext cx="402336" cy="402336"/>
           </a:xfrm>
           <a:prstGeom prst="ellipse">
             <a:avLst/>
           </a:prstGeom>
           <a:solidFill>
-            <a:srgbClr val="003087"/>
+            <a:srgbClr val="2D5A27"/>
           </a:solidFill>
           <a:ln/>
         </p:spPr>
@@ -2779,8 +2779,8 @@
         </p:nvSpPr>
         <p:spPr>
           <a:xfrm>
-            <a:off x="594360" y="2103120"/>
-            <a:ext cx="365760" cy="365760"/>
+            <a:off x="576072" y="2084832"/>
+            <a:ext cx="402336" cy="402336"/>
           </a:xfrm>
           <a:prstGeom prst="rect">
             <a:avLst/>
@@ -2796,9 +2796,9 @@
               <a:buNone/>
             </a:pPr>
             <a:r>
-              <a:rPr lang="en-US" sz="1100" b="1" dirty="0">
+              <a:rPr lang="en-US" sz="1200" b="1" dirty="0">
                 <a:solidFill>
-                  <a:srgbClr val="FFFFFF"/>
+                  <a:srgbClr val="FFFEF9"/>
                 </a:solidFill>
                 <a:latin typeface="Calibri" pitchFamily="34" charset="0"/>
                 <a:ea typeface="Calibri" pitchFamily="34" charset="-122"/>
@@ -2806,7 +2806,7 @@
               </a:rPr>
               <a:t>3</a:t>
             </a:r>
-            <a:endParaRPr lang="en-US" sz="1100" dirty="0"/>
+            <a:endParaRPr lang="en-US" sz="1200" dirty="0"/>
           </a:p>
         </p:txBody>
       </p:sp>
@@ -2837,7 +2837,7 @@
             <a:r>
               <a:rPr lang="en-US" sz="1600" dirty="0">
                 <a:solidFill>
-                  <a:srgbClr val="333333"/>
+                  <a:srgbClr val="3D3D3D"/>
                 </a:solidFill>
                 <a:latin typeface="Calibri" pitchFamily="34" charset="0"/>
                 <a:ea typeface="Calibri" pitchFamily="34" charset="-122"/>
@@ -2857,14 +2857,14 @@
         </p:nvSpPr>
         <p:spPr>
           <a:xfrm>
-            <a:off x="594360" y="2560320"/>
-            <a:ext cx="365760" cy="365760"/>
+            <a:off x="576072" y="2542032"/>
+            <a:ext cx="402336" cy="402336"/>
           </a:xfrm>
           <a:prstGeom prst="ellipse">
             <a:avLst/>
           </a:prstGeom>
           <a:solidFill>
-            <a:srgbClr val="003087"/>
+            <a:srgbClr val="2D5A27"/>
           </a:solidFill>
           <a:ln/>
         </p:spPr>
@@ -2877,8 +2877,8 @@
         </p:nvSpPr>
         <p:spPr>
           <a:xfrm>
-            <a:off x="594360" y="2560320"/>
-            <a:ext cx="365760" cy="365760"/>
+            <a:off x="576072" y="2542032"/>
+            <a:ext cx="402336" cy="402336"/>
           </a:xfrm>
           <a:prstGeom prst="rect">
             <a:avLst/>
@@ -2894,9 +2894,9 @@
               <a:buNone/>
             </a:pPr>
             <a:r>
-              <a:rPr lang="en-US" sz="1100" b="1" dirty="0">
+              <a:rPr lang="en-US" sz="1200" b="1" dirty="0">
                 <a:solidFill>
-                  <a:srgbClr val="FFFFFF"/>
+                  <a:srgbClr val="FFFEF9"/>
                 </a:solidFill>
                 <a:latin typeface="Calibri" pitchFamily="34" charset="0"/>
                 <a:ea typeface="Calibri" pitchFamily="34" charset="-122"/>
@@ -2904,7 +2904,7 @@
               </a:rPr>
               <a:t>4</a:t>
             </a:r>
-            <a:endParaRPr lang="en-US" sz="1100" dirty="0"/>
+            <a:endParaRPr lang="en-US" sz="1200" dirty="0"/>
           </a:p>
         </p:txBody>
       </p:sp>
@@ -2935,7 +2935,7 @@
             <a:r>
               <a:rPr lang="en-US" sz="1600" dirty="0">
                 <a:solidFill>
-                  <a:srgbClr val="333333"/>
+                  <a:srgbClr val="3D3D3D"/>
                 </a:solidFill>
                 <a:latin typeface="Calibri" pitchFamily="34" charset="0"/>
                 <a:ea typeface="Calibri" pitchFamily="34" charset="-122"/>
@@ -2955,14 +2955,14 @@
         </p:nvSpPr>
         <p:spPr>
           <a:xfrm>
-            <a:off x="594360" y="3017520"/>
-            <a:ext cx="365760" cy="365760"/>
+            <a:off x="576072" y="2999232"/>
+            <a:ext cx="402336" cy="402336"/>
           </a:xfrm>
           <a:prstGeom prst="ellipse">
             <a:avLst/>
           </a:prstGeom>
           <a:solidFill>
-            <a:srgbClr val="003087"/>
+            <a:srgbClr val="2D5A27"/>
           </a:solidFill>
           <a:ln/>
         </p:spPr>
@@ -2975,8 +2975,8 @@
         </p:nvSpPr>
         <p:spPr>
           <a:xfrm>
-            <a:off x="594360" y="3017520"/>
-            <a:ext cx="365760" cy="365760"/>
+            <a:off x="576072" y="2999232"/>
+            <a:ext cx="402336" cy="402336"/>
           </a:xfrm>
           <a:prstGeom prst="rect">
             <a:avLst/>
@@ -2992,9 +2992,9 @@
               <a:buNone/>
             </a:pPr>
             <a:r>
-              <a:rPr lang="en-US" sz="1100" b="1" dirty="0">
+              <a:rPr lang="en-US" sz="1200" b="1" dirty="0">
                 <a:solidFill>
-                  <a:srgbClr val="FFFFFF"/>
+                  <a:srgbClr val="FFFEF9"/>
                 </a:solidFill>
                 <a:latin typeface="Calibri" pitchFamily="34" charset="0"/>
                 <a:ea typeface="Calibri" pitchFamily="34" charset="-122"/>
@@ -3002,7 +3002,7 @@
               </a:rPr>
               <a:t>5</a:t>
             </a:r>
-            <a:endParaRPr lang="en-US" sz="1100" dirty="0"/>
+            <a:endParaRPr lang="en-US" sz="1200" dirty="0"/>
           </a:p>
         </p:txBody>
       </p:sp>
@@ -3033,7 +3033,7 @@
             <a:r>
               <a:rPr lang="en-US" sz="1600" dirty="0">
                 <a:solidFill>
-                  <a:srgbClr val="333333"/>
+                  <a:srgbClr val="3D3D3D"/>
                 </a:solidFill>
                 <a:latin typeface="Calibri" pitchFamily="34" charset="0"/>
                 <a:ea typeface="Calibri" pitchFamily="34" charset="-122"/>
@@ -3053,14 +3053,14 @@
         </p:nvSpPr>
         <p:spPr>
           <a:xfrm>
-            <a:off x="594360" y="3474720"/>
-            <a:ext cx="365760" cy="365760"/>
+            <a:off x="576072" y="3456432"/>
+            <a:ext cx="402336" cy="402336"/>
           </a:xfrm>
           <a:prstGeom prst="ellipse">
             <a:avLst/>
           </a:prstGeom>
           <a:solidFill>
-            <a:srgbClr val="003087"/>
+            <a:srgbClr val="2D5A27"/>
           </a:solidFill>
           <a:ln/>
         </p:spPr>
@@ -3073,8 +3073,8 @@
         </p:nvSpPr>
         <p:spPr>
           <a:xfrm>
-            <a:off x="594360" y="3474720"/>
-            <a:ext cx="365760" cy="365760"/>
+            <a:off x="576072" y="3456432"/>
+            <a:ext cx="402336" cy="402336"/>
           </a:xfrm>
           <a:prstGeom prst="rect">
             <a:avLst/>
@@ -3090,9 +3090,9 @@
               <a:buNone/>
             </a:pPr>
             <a:r>
-              <a:rPr lang="en-US" sz="1100" b="1" dirty="0">
+              <a:rPr lang="en-US" sz="1200" b="1" dirty="0">
                 <a:solidFill>
-                  <a:srgbClr val="FFFFFF"/>
+                  <a:srgbClr val="FFFEF9"/>
                 </a:solidFill>
                 <a:latin typeface="Calibri" pitchFamily="34" charset="0"/>
                 <a:ea typeface="Calibri" pitchFamily="34" charset="-122"/>
@@ -3100,7 +3100,7 @@
               </a:rPr>
               <a:t>6</a:t>
             </a:r>
-            <a:endParaRPr lang="en-US" sz="1100" dirty="0"/>
+            <a:endParaRPr lang="en-US" sz="1200" dirty="0"/>
           </a:p>
         </p:txBody>
       </p:sp>
@@ -3131,7 +3131,7 @@
             <a:r>
               <a:rPr lang="en-US" sz="1600" dirty="0">
                 <a:solidFill>
-                  <a:srgbClr val="333333"/>
+                  <a:srgbClr val="3D3D3D"/>
                 </a:solidFill>
                 <a:latin typeface="Calibri" pitchFamily="34" charset="0"/>
                 <a:ea typeface="Calibri" pitchFamily="34" charset="-122"/>
@@ -3151,14 +3151,14 @@
         </p:nvSpPr>
         <p:spPr>
           <a:xfrm>
-            <a:off x="594360" y="3931920"/>
-            <a:ext cx="365760" cy="365760"/>
+            <a:off x="576072" y="3913632"/>
+            <a:ext cx="402336" cy="402336"/>
           </a:xfrm>
           <a:prstGeom prst="ellipse">
             <a:avLst/>
           </a:prstGeom>
           <a:solidFill>
-            <a:srgbClr val="003087"/>
+            <a:srgbClr val="2D5A27"/>
           </a:solidFill>
           <a:ln/>
         </p:spPr>
@@ -3171,8 +3171,8 @@
         </p:nvSpPr>
         <p:spPr>
           <a:xfrm>
-            <a:off x="594360" y="3931920"/>
-            <a:ext cx="365760" cy="365760"/>
+            <a:off x="576072" y="3913632"/>
+            <a:ext cx="402336" cy="402336"/>
           </a:xfrm>
           <a:prstGeom prst="rect">
             <a:avLst/>
@@ -3188,9 +3188,9 @@
               <a:buNone/>
             </a:pPr>
             <a:r>
-              <a:rPr lang="en-US" sz="1100" b="1" dirty="0">
+              <a:rPr lang="en-US" sz="1200" b="1" dirty="0">
                 <a:solidFill>
-                  <a:srgbClr val="FFFFFF"/>
+                  <a:srgbClr val="FFFEF9"/>
                 </a:solidFill>
                 <a:latin typeface="Calibri" pitchFamily="34" charset="0"/>
                 <a:ea typeface="Calibri" pitchFamily="34" charset="-122"/>
@@ -3198,7 +3198,7 @@
               </a:rPr>
               <a:t>7</a:t>
             </a:r>
-            <a:endParaRPr lang="en-US" sz="1100" dirty="0"/>
+            <a:endParaRPr lang="en-US" sz="1200" dirty="0"/>
           </a:p>
         </p:txBody>
       </p:sp>
@@ -3229,7 +3229,7 @@
             <a:r>
               <a:rPr lang="en-US" sz="1600" dirty="0">
                 <a:solidFill>
-                  <a:srgbClr val="333333"/>
+                  <a:srgbClr val="3D3D3D"/>
                 </a:solidFill>
                 <a:latin typeface="Calibri" pitchFamily="34" charset="0"/>
                 <a:ea typeface="Calibri" pitchFamily="34" charset="-122"/>
@@ -3249,14 +3249,14 @@
         </p:nvSpPr>
         <p:spPr>
           <a:xfrm>
-            <a:off x="594360" y="4389120"/>
-            <a:ext cx="365760" cy="365760"/>
+            <a:off x="576072" y="4370832"/>
+            <a:ext cx="402336" cy="402336"/>
           </a:xfrm>
           <a:prstGeom prst="ellipse">
             <a:avLst/>
           </a:prstGeom>
           <a:solidFill>
-            <a:srgbClr val="003087"/>
+            <a:srgbClr val="2D5A27"/>
           </a:solidFill>
           <a:ln/>
         </p:spPr>
@@ -3269,8 +3269,8 @@
         </p:nvSpPr>
         <p:spPr>
           <a:xfrm>
-            <a:off x="594360" y="4389120"/>
-            <a:ext cx="365760" cy="365760"/>
+            <a:off x="576072" y="4370832"/>
+            <a:ext cx="402336" cy="402336"/>
           </a:xfrm>
           <a:prstGeom prst="rect">
             <a:avLst/>
@@ -3286,9 +3286,9 @@
               <a:buNone/>
             </a:pPr>
             <a:r>
-              <a:rPr lang="en-US" sz="1100" b="1" dirty="0">
+              <a:rPr lang="en-US" sz="1200" b="1" dirty="0">
                 <a:solidFill>
-                  <a:srgbClr val="FFFFFF"/>
+                  <a:srgbClr val="FFFEF9"/>
                 </a:solidFill>
                 <a:latin typeface="Calibri" pitchFamily="34" charset="0"/>
                 <a:ea typeface="Calibri" pitchFamily="34" charset="-122"/>
@@ -3296,7 +3296,7 @@
               </a:rPr>
               <a:t>8</a:t>
             </a:r>
-            <a:endParaRPr lang="en-US" sz="1100" dirty="0"/>
+            <a:endParaRPr lang="en-US" sz="1200" dirty="0"/>
           </a:p>
         </p:txBody>
       </p:sp>
@@ -3327,7 +3327,7 @@
             <a:r>
               <a:rPr lang="en-US" sz="1600" dirty="0">
                 <a:solidFill>
-                  <a:srgbClr val="333333"/>
+                  <a:srgbClr val="3D3D3D"/>
                 </a:solidFill>
                 <a:latin typeface="Calibri" pitchFamily="34" charset="0"/>
                 <a:ea typeface="Calibri" pitchFamily="34" charset="-122"/>
@@ -3353,7 +3353,7 @@
     <p:bg>
       <p:bgPr>
         <a:solidFill>
-          <a:srgbClr val="F5F5F5"/>
+          <a:srgbClr val="FDF8F3"/>
         </a:solidFill>
       </p:bgPr>
     </p:bg>
@@ -3398,7 +3398,7 @@
             <a:r>
               <a:rPr lang="en-US" sz="2600" b="1" dirty="0">
                 <a:solidFill>
-                  <a:srgbClr val="003087"/>
+                  <a:srgbClr val="2D5A27"/>
                 </a:solidFill>
                 <a:latin typeface="Georgia" pitchFamily="34" charset="0"/>
                 <a:ea typeface="Georgia" pitchFamily="34" charset="-122"/>
@@ -3425,7 +3425,7 @@
             <a:avLst/>
           </a:prstGeom>
           <a:solidFill>
-            <a:srgbClr val="E67E22"/>
+            <a:srgbClr val="D4A574"/>
           </a:solidFill>
           <a:ln/>
         </p:spPr>
@@ -3444,7 +3444,7 @@
     <p:bg>
       <p:bgPr>
         <a:solidFill>
-          <a:srgbClr val="F5F5F5"/>
+          <a:srgbClr val="FDF8F3"/>
         </a:solidFill>
       </p:bgPr>
     </p:bg>
@@ -3489,7 +3489,7 @@
             <a:r>
               <a:rPr lang="en-US" sz="2600" b="1" dirty="0">
                 <a:solidFill>
-                  <a:srgbClr val="003087"/>
+                  <a:srgbClr val="2D5A27"/>
                 </a:solidFill>
                 <a:latin typeface="Georgia" pitchFamily="34" charset="0"/>
                 <a:ea typeface="Georgia" pitchFamily="34" charset="-122"/>
@@ -3516,7 +3516,7 @@
             <a:avLst/>
           </a:prstGeom>
           <a:solidFill>
-            <a:srgbClr val="E67E22"/>
+            <a:srgbClr val="D4A574"/>
           </a:solidFill>
           <a:ln/>
         </p:spPr>
@@ -3529,7 +3529,7 @@
         </p:nvSpPr>
         <p:spPr>
           <a:xfrm>
-            <a:off x="576072" y="1033272"/>
+            <a:off x="585216" y="1042416"/>
             <a:ext cx="8046720" cy="685800"/>
           </a:xfrm>
           <a:prstGeom prst="roundRect">
@@ -3538,7 +3538,7 @@
             </a:avLst>
           </a:prstGeom>
           <a:solidFill>
-            <a:srgbClr val="DDDDDD"/>
+            <a:srgbClr val="D9D4CB"/>
           </a:solidFill>
           <a:ln/>
         </p:spPr>
@@ -3560,7 +3560,7 @@
             </a:avLst>
           </a:prstGeom>
           <a:solidFill>
-            <a:srgbClr val="FFFFFF"/>
+            <a:srgbClr val="FFFEF9"/>
           </a:solidFill>
           <a:ln/>
         </p:spPr>
@@ -3574,13 +3574,13 @@
         <p:spPr>
           <a:xfrm>
             <a:off x="548640" y="1005840"/>
-            <a:ext cx="73152" cy="685800"/>
-          </a:xfrm>
-          <a:prstGeom prst="rect">
-            <a:avLst/>
-          </a:prstGeom>
-          <a:solidFill>
-            <a:srgbClr val="003087"/>
+            <a:ext cx="91440" cy="685800"/>
+          </a:xfrm>
+          <a:prstGeom prst="rect">
+            <a:avLst/>
+          </a:prstGeom>
+          <a:solidFill>
+            <a:srgbClr val="2D5A27"/>
           </a:solidFill>
           <a:ln/>
         </p:spPr>
@@ -3593,14 +3593,14 @@
         </p:nvSpPr>
         <p:spPr>
           <a:xfrm>
-            <a:off x="685800" y="1165860"/>
-            <a:ext cx="365760" cy="365760"/>
+            <a:off x="667512" y="1147572"/>
+            <a:ext cx="402336" cy="402336"/>
           </a:xfrm>
           <a:prstGeom prst="ellipse">
             <a:avLst/>
           </a:prstGeom>
           <a:solidFill>
-            <a:srgbClr val="003087"/>
+            <a:srgbClr val="2D5A27"/>
           </a:solidFill>
           <a:ln/>
         </p:spPr>
@@ -3613,8 +3613,8 @@
         </p:nvSpPr>
         <p:spPr>
           <a:xfrm>
-            <a:off x="685800" y="1165860"/>
-            <a:ext cx="365760" cy="365760"/>
+            <a:off x="667512" y="1147572"/>
+            <a:ext cx="402336" cy="402336"/>
           </a:xfrm>
           <a:prstGeom prst="rect">
             <a:avLst/>
@@ -3630,9 +3630,9 @@
               <a:buNone/>
             </a:pPr>
             <a:r>
-              <a:rPr lang="en-US" sz="1100" b="1" dirty="0">
+              <a:rPr lang="en-US" sz="1200" b="1" dirty="0">
                 <a:solidFill>
-                  <a:srgbClr val="FFFFFF"/>
+                  <a:srgbClr val="FFFEF9"/>
                 </a:solidFill>
                 <a:latin typeface="Calibri" pitchFamily="34" charset="0"/>
                 <a:ea typeface="Calibri" pitchFamily="34" charset="-122"/>
@@ -3640,7 +3640,7 @@
               </a:rPr>
               <a:t>1</a:t>
             </a:r>
-            <a:endParaRPr lang="en-US" sz="1100" dirty="0"/>
+            <a:endParaRPr lang="en-US" sz="1200" dirty="0"/>
           </a:p>
         </p:txBody>
       </p:sp>
@@ -3671,7 +3671,7 @@
             <a:r>
               <a:rPr lang="en-US" sz="1400" dirty="0">
                 <a:solidFill>
-                  <a:srgbClr val="333333"/>
+                  <a:srgbClr val="3D3D3D"/>
                 </a:solidFill>
                 <a:latin typeface="Calibri" pitchFamily="34" charset="0"/>
                 <a:ea typeface="Calibri" pitchFamily="34" charset="-122"/>
@@ -3691,7 +3691,7 @@
         </p:nvSpPr>
         <p:spPr>
           <a:xfrm>
-            <a:off x="576072" y="1856232"/>
+            <a:off x="585216" y="1865376"/>
             <a:ext cx="8046720" cy="685800"/>
           </a:xfrm>
           <a:prstGeom prst="roundRect">
@@ -3700,7 +3700,7 @@
             </a:avLst>
           </a:prstGeom>
           <a:solidFill>
-            <a:srgbClr val="DDDDDD"/>
+            <a:srgbClr val="D9D4CB"/>
           </a:solidFill>
           <a:ln/>
         </p:spPr>
@@ -3722,7 +3722,7 @@
             </a:avLst>
           </a:prstGeom>
           <a:solidFill>
-            <a:srgbClr val="FFFFFF"/>
+            <a:srgbClr val="FFFEF9"/>
           </a:solidFill>
           <a:ln/>
         </p:spPr>
@@ -3736,13 +3736,13 @@
         <p:spPr>
           <a:xfrm>
             <a:off x="548640" y="1828800"/>
-            <a:ext cx="73152" cy="685800"/>
-          </a:xfrm>
-          <a:prstGeom prst="rect">
-            <a:avLst/>
-          </a:prstGeom>
-          <a:solidFill>
-            <a:srgbClr val="003087"/>
+            <a:ext cx="91440" cy="685800"/>
+          </a:xfrm>
+          <a:prstGeom prst="rect">
+            <a:avLst/>
+          </a:prstGeom>
+          <a:solidFill>
+            <a:srgbClr val="2D5A27"/>
           </a:solidFill>
           <a:ln/>
         </p:spPr>
@@ -3755,14 +3755,14 @@
         </p:nvSpPr>
         <p:spPr>
           <a:xfrm>
-            <a:off x="685800" y="1988820"/>
-            <a:ext cx="365760" cy="365760"/>
+            <a:off x="667512" y="1970532"/>
+            <a:ext cx="402336" cy="402336"/>
           </a:xfrm>
           <a:prstGeom prst="ellipse">
             <a:avLst/>
           </a:prstGeom>
           <a:solidFill>
-            <a:srgbClr val="003087"/>
+            <a:srgbClr val="2D5A27"/>
           </a:solidFill>
           <a:ln/>
         </p:spPr>
@@ -3775,8 +3775,8 @@
         </p:nvSpPr>
         <p:spPr>
           <a:xfrm>
-            <a:off x="685800" y="1988820"/>
-            <a:ext cx="365760" cy="365760"/>
+            <a:off x="667512" y="1970532"/>
+            <a:ext cx="402336" cy="402336"/>
           </a:xfrm>
           <a:prstGeom prst="rect">
             <a:avLst/>
@@ -3792,9 +3792,9 @@
               <a:buNone/>
             </a:pPr>
             <a:r>
-              <a:rPr lang="en-US" sz="1100" b="1" dirty="0">
+              <a:rPr lang="en-US" sz="1200" b="1" dirty="0">
                 <a:solidFill>
-                  <a:srgbClr val="FFFFFF"/>
+                  <a:srgbClr val="FFFEF9"/>
                 </a:solidFill>
                 <a:latin typeface="Calibri" pitchFamily="34" charset="0"/>
                 <a:ea typeface="Calibri" pitchFamily="34" charset="-122"/>
@@ -3802,7 +3802,7 @@
               </a:rPr>
               <a:t>2</a:t>
             </a:r>
-            <a:endParaRPr lang="en-US" sz="1100" dirty="0"/>
+            <a:endParaRPr lang="en-US" sz="1200" dirty="0"/>
           </a:p>
         </p:txBody>
       </p:sp>
@@ -3833,7 +3833,7 @@
             <a:r>
               <a:rPr lang="en-US" sz="1400" dirty="0">
                 <a:solidFill>
-                  <a:srgbClr val="333333"/>
+                  <a:srgbClr val="3D3D3D"/>
                 </a:solidFill>
                 <a:latin typeface="Calibri" pitchFamily="34" charset="0"/>
                 <a:ea typeface="Calibri" pitchFamily="34" charset="-122"/>
@@ -3853,7 +3853,7 @@
         </p:nvSpPr>
         <p:spPr>
           <a:xfrm>
-            <a:off x="576072" y="2679192"/>
+            <a:off x="585216" y="2688336"/>
             <a:ext cx="8046720" cy="685800"/>
           </a:xfrm>
           <a:prstGeom prst="roundRect">
@@ -3862,7 +3862,7 @@
             </a:avLst>
           </a:prstGeom>
           <a:solidFill>
-            <a:srgbClr val="DDDDDD"/>
+            <a:srgbClr val="D9D4CB"/>
           </a:solidFill>
           <a:ln/>
         </p:spPr>
@@ -3884,7 +3884,7 @@
             </a:avLst>
           </a:prstGeom>
           <a:solidFill>
-            <a:srgbClr val="FFFFFF"/>
+            <a:srgbClr val="FFFEF9"/>
           </a:solidFill>
           <a:ln/>
         </p:spPr>
@@ -3898,13 +3898,13 @@
         <p:spPr>
           <a:xfrm>
             <a:off x="548640" y="2651760"/>
-            <a:ext cx="73152" cy="685800"/>
-          </a:xfrm>
-          <a:prstGeom prst="rect">
-            <a:avLst/>
-          </a:prstGeom>
-          <a:solidFill>
-            <a:srgbClr val="003087"/>
+            <a:ext cx="91440" cy="685800"/>
+          </a:xfrm>
+          <a:prstGeom prst="rect">
+            <a:avLst/>
+          </a:prstGeom>
+          <a:solidFill>
+            <a:srgbClr val="2D5A27"/>
           </a:solidFill>
           <a:ln/>
         </p:spPr>
@@ -3917,14 +3917,14 @@
         </p:nvSpPr>
         <p:spPr>
           <a:xfrm>
-            <a:off x="685800" y="2811780"/>
-            <a:ext cx="365760" cy="365760"/>
+            <a:off x="667512" y="2793492"/>
+            <a:ext cx="402336" cy="402336"/>
           </a:xfrm>
           <a:prstGeom prst="ellipse">
             <a:avLst/>
           </a:prstGeom>
           <a:solidFill>
-            <a:srgbClr val="003087"/>
+            <a:srgbClr val="2D5A27"/>
           </a:solidFill>
           <a:ln/>
         </p:spPr>
@@ -3937,8 +3937,8 @@
         </p:nvSpPr>
         <p:spPr>
           <a:xfrm>
-            <a:off x="685800" y="2811780"/>
-            <a:ext cx="365760" cy="365760"/>
+            <a:off x="667512" y="2793492"/>
+            <a:ext cx="402336" cy="402336"/>
           </a:xfrm>
           <a:prstGeom prst="rect">
             <a:avLst/>
@@ -3954,9 +3954,9 @@
               <a:buNone/>
             </a:pPr>
             <a:r>
-              <a:rPr lang="en-US" sz="1100" b="1" dirty="0">
+              <a:rPr lang="en-US" sz="1200" b="1" dirty="0">
                 <a:solidFill>
-                  <a:srgbClr val="FFFFFF"/>
+                  <a:srgbClr val="FFFEF9"/>
                 </a:solidFill>
                 <a:latin typeface="Calibri" pitchFamily="34" charset="0"/>
                 <a:ea typeface="Calibri" pitchFamily="34" charset="-122"/>
@@ -3964,7 +3964,7 @@
               </a:rPr>
               <a:t>3</a:t>
             </a:r>
-            <a:endParaRPr lang="en-US" sz="1100" dirty="0"/>
+            <a:endParaRPr lang="en-US" sz="1200" dirty="0"/>
           </a:p>
         </p:txBody>
       </p:sp>
@@ -3995,7 +3995,7 @@
             <a:r>
               <a:rPr lang="en-US" sz="1400" dirty="0">
                 <a:solidFill>
-                  <a:srgbClr val="333333"/>
+                  <a:srgbClr val="3D3D3D"/>
                 </a:solidFill>
                 <a:latin typeface="Calibri" pitchFamily="34" charset="0"/>
                 <a:ea typeface="Calibri" pitchFamily="34" charset="-122"/>
@@ -4015,7 +4015,7 @@
         </p:nvSpPr>
         <p:spPr>
           <a:xfrm>
-            <a:off x="576072" y="3502152"/>
+            <a:off x="585216" y="3511296"/>
             <a:ext cx="8046720" cy="685800"/>
           </a:xfrm>
           <a:prstGeom prst="roundRect">
@@ -4024,7 +4024,7 @@
             </a:avLst>
           </a:prstGeom>
           <a:solidFill>
-            <a:srgbClr val="DDDDDD"/>
+            <a:srgbClr val="D9D4CB"/>
           </a:solidFill>
           <a:ln/>
         </p:spPr>
@@ -4046,7 +4046,7 @@
             </a:avLst>
           </a:prstGeom>
           <a:solidFill>
-            <a:srgbClr val="FFFFFF"/>
+            <a:srgbClr val="FFFEF9"/>
           </a:solidFill>
           <a:ln/>
         </p:spPr>
@@ -4060,13 +4060,13 @@
         <p:spPr>
           <a:xfrm>
             <a:off x="548640" y="3474720"/>
-            <a:ext cx="73152" cy="685800"/>
-          </a:xfrm>
-          <a:prstGeom prst="rect">
-            <a:avLst/>
-          </a:prstGeom>
-          <a:solidFill>
-            <a:srgbClr val="003087"/>
+            <a:ext cx="91440" cy="685800"/>
+          </a:xfrm>
+          <a:prstGeom prst="rect">
+            <a:avLst/>
+          </a:prstGeom>
+          <a:solidFill>
+            <a:srgbClr val="2D5A27"/>
           </a:solidFill>
           <a:ln/>
         </p:spPr>
@@ -4079,14 +4079,14 @@
         </p:nvSpPr>
         <p:spPr>
           <a:xfrm>
-            <a:off x="685800" y="3634740"/>
-            <a:ext cx="365760" cy="365760"/>
+            <a:off x="667512" y="3616452"/>
+            <a:ext cx="402336" cy="402336"/>
           </a:xfrm>
           <a:prstGeom prst="ellipse">
             <a:avLst/>
           </a:prstGeom>
           <a:solidFill>
-            <a:srgbClr val="003087"/>
+            <a:srgbClr val="2D5A27"/>
           </a:solidFill>
           <a:ln/>
         </p:spPr>
@@ -4099,8 +4099,8 @@
         </p:nvSpPr>
         <p:spPr>
           <a:xfrm>
-            <a:off x="685800" y="3634740"/>
-            <a:ext cx="365760" cy="365760"/>
+            <a:off x="667512" y="3616452"/>
+            <a:ext cx="402336" cy="402336"/>
           </a:xfrm>
           <a:prstGeom prst="rect">
             <a:avLst/>
@@ -4116,9 +4116,9 @@
               <a:buNone/>
             </a:pPr>
             <a:r>
-              <a:rPr lang="en-US" sz="1100" b="1" dirty="0">
+              <a:rPr lang="en-US" sz="1200" b="1" dirty="0">
                 <a:solidFill>
-                  <a:srgbClr val="FFFFFF"/>
+                  <a:srgbClr val="FFFEF9"/>
                 </a:solidFill>
                 <a:latin typeface="Calibri" pitchFamily="34" charset="0"/>
                 <a:ea typeface="Calibri" pitchFamily="34" charset="-122"/>
@@ -4126,7 +4126,7 @@
               </a:rPr>
               <a:t>4</a:t>
             </a:r>
-            <a:endParaRPr lang="en-US" sz="1100" dirty="0"/>
+            <a:endParaRPr lang="en-US" sz="1200" dirty="0"/>
           </a:p>
         </p:txBody>
       </p:sp>
@@ -4157,7 +4157,7 @@
             <a:r>
               <a:rPr lang="en-US" sz="1400" dirty="0">
                 <a:solidFill>
-                  <a:srgbClr val="333333"/>
+                  <a:srgbClr val="3D3D3D"/>
                 </a:solidFill>
                 <a:latin typeface="Calibri" pitchFamily="34" charset="0"/>
                 <a:ea typeface="Calibri" pitchFamily="34" charset="-122"/>
@@ -4186,7 +4186,7 @@
             </a:avLst>
           </a:prstGeom>
           <a:solidFill>
-            <a:srgbClr val="003087"/>
+            <a:srgbClr val="2D5A27"/>
           </a:solidFill>
           <a:ln/>
         </p:spPr>
@@ -4218,7 +4218,7 @@
             <a:r>
               <a:rPr lang="en-US" sz="1300" i="1" dirty="0">
                 <a:solidFill>
-                  <a:srgbClr val="FFFFFF"/>
+                  <a:srgbClr val="FFFEF9"/>
                 </a:solidFill>
                 <a:latin typeface="Calibri" pitchFamily="34" charset="0"/>
                 <a:ea typeface="Calibri" pitchFamily="34" charset="-122"/>
@@ -4247,7 +4247,7 @@
             </a:avLst>
           </a:prstGeom>
           <a:solidFill>
-            <a:srgbClr val="003087"/>
+            <a:srgbClr val="2D5A27"/>
           </a:solidFill>
           <a:ln/>
         </p:spPr>
@@ -4279,7 +4279,7 @@
             <a:r>
               <a:rPr lang="en-US" sz="1300" i="1" dirty="0">
                 <a:solidFill>
-                  <a:srgbClr val="FFFFFF"/>
+                  <a:srgbClr val="FFFEF9"/>
                 </a:solidFill>
                 <a:latin typeface="Calibri" pitchFamily="34" charset="0"/>
                 <a:ea typeface="Calibri" pitchFamily="34" charset="-122"/>
@@ -4305,7 +4305,7 @@
     <p:bg>
       <p:bgPr>
         <a:solidFill>
-          <a:srgbClr val="F5F5F5"/>
+          <a:srgbClr val="FDF8F3"/>
         </a:solidFill>
       </p:bgPr>
     </p:bg>
@@ -4350,7 +4350,7 @@
             <a:r>
               <a:rPr lang="en-US" sz="2600" b="1" dirty="0">
                 <a:solidFill>
-                  <a:srgbClr val="003087"/>
+                  <a:srgbClr val="2D5A27"/>
                 </a:solidFill>
                 <a:latin typeface="Georgia" pitchFamily="34" charset="0"/>
                 <a:ea typeface="Georgia" pitchFamily="34" charset="-122"/>
@@ -4377,7 +4377,7 @@
             <a:avLst/>
           </a:prstGeom>
           <a:solidFill>
-            <a:srgbClr val="E67E22"/>
+            <a:srgbClr val="D4A574"/>
           </a:solidFill>
           <a:ln/>
         </p:spPr>
@@ -4399,7 +4399,7 @@
             </a:avLst>
           </a:prstGeom>
           <a:solidFill>
-            <a:srgbClr val="003087"/>
+            <a:srgbClr val="2D5A27"/>
           </a:solidFill>
           <a:ln/>
         </p:spPr>
@@ -4431,7 +4431,7 @@
             <a:r>
               <a:rPr lang="en-US" sz="1300" i="1" dirty="0">
                 <a:solidFill>
-                  <a:srgbClr val="FFFFFF"/>
+                  <a:srgbClr val="FFFEF9"/>
                 </a:solidFill>
                 <a:latin typeface="Calibri" pitchFamily="34" charset="0"/>
                 <a:ea typeface="Calibri" pitchFamily="34" charset="-122"/>
@@ -4460,7 +4460,7 @@
             </a:avLst>
           </a:prstGeom>
           <a:solidFill>
-            <a:srgbClr val="003087"/>
+            <a:srgbClr val="2D5A27"/>
           </a:solidFill>
           <a:ln/>
         </p:spPr>
@@ -4492,7 +4492,7 @@
             <a:r>
               <a:rPr lang="en-US" sz="1300" i="1" dirty="0">
                 <a:solidFill>
-                  <a:srgbClr val="FFFFFF"/>
+                  <a:srgbClr val="FFFEF9"/>
                 </a:solidFill>
                 <a:latin typeface="Calibri" pitchFamily="34" charset="0"/>
                 <a:ea typeface="Calibri" pitchFamily="34" charset="-122"/>
@@ -4518,7 +4518,7 @@
     <p:bg>
       <p:bgPr>
         <a:solidFill>
-          <a:srgbClr val="F5F5F5"/>
+          <a:srgbClr val="FDF8F3"/>
         </a:solidFill>
       </p:bgPr>
     </p:bg>
@@ -4563,7 +4563,7 @@
             <a:r>
               <a:rPr lang="en-US" sz="2600" b="1" dirty="0">
                 <a:solidFill>
-                  <a:srgbClr val="003087"/>
+                  <a:srgbClr val="2D5A27"/>
                 </a:solidFill>
                 <a:latin typeface="Georgia" pitchFamily="34" charset="0"/>
                 <a:ea typeface="Georgia" pitchFamily="34" charset="-122"/>
@@ -4590,7 +4590,7 @@
             <a:avLst/>
           </a:prstGeom>
           <a:solidFill>
-            <a:srgbClr val="E67E22"/>
+            <a:srgbClr val="D4A574"/>
           </a:solidFill>
           <a:ln/>
         </p:spPr>
@@ -4612,7 +4612,7 @@
             </a:avLst>
           </a:prstGeom>
           <a:solidFill>
-            <a:srgbClr val="003087"/>
+            <a:srgbClr val="2D5A27"/>
           </a:solidFill>
           <a:ln/>
         </p:spPr>
@@ -4644,7 +4644,7 @@
             <a:r>
               <a:rPr lang="en-US" sz="1300" i="1" dirty="0">
                 <a:solidFill>
-                  <a:srgbClr val="FFFFFF"/>
+                  <a:srgbClr val="FFFEF9"/>
                 </a:solidFill>
                 <a:latin typeface="Calibri" pitchFamily="34" charset="0"/>
                 <a:ea typeface="Calibri" pitchFamily="34" charset="-122"/>
@@ -4673,7 +4673,7 @@
             </a:avLst>
           </a:prstGeom>
           <a:solidFill>
-            <a:srgbClr val="003087"/>
+            <a:srgbClr val="2D5A27"/>
           </a:solidFill>
           <a:ln/>
         </p:spPr>
@@ -4705,7 +4705,7 @@
             <a:r>
               <a:rPr lang="en-US" sz="1300" i="1" dirty="0">
                 <a:solidFill>
-                  <a:srgbClr val="FFFFFF"/>
+                  <a:srgbClr val="FFFEF9"/>
                 </a:solidFill>
                 <a:latin typeface="Calibri" pitchFamily="34" charset="0"/>
                 <a:ea typeface="Calibri" pitchFamily="34" charset="-122"/>
@@ -4731,7 +4731,7 @@
     <p:bg>
       <p:bgPr>
         <a:solidFill>
-          <a:srgbClr val="F5F5F5"/>
+          <a:srgbClr val="FDF8F3"/>
         </a:solidFill>
       </p:bgPr>
     </p:bg>
@@ -4776,7 +4776,7 @@
             <a:r>
               <a:rPr lang="en-US" sz="2600" b="1" dirty="0">
                 <a:solidFill>
-                  <a:srgbClr val="003087"/>
+                  <a:srgbClr val="2D5A27"/>
                 </a:solidFill>
                 <a:latin typeface="Georgia" pitchFamily="34" charset="0"/>
                 <a:ea typeface="Georgia" pitchFamily="34" charset="-122"/>
@@ -4803,7 +4803,7 @@
             <a:avLst/>
           </a:prstGeom>
           <a:solidFill>
-            <a:srgbClr val="E67E22"/>
+            <a:srgbClr val="D4A574"/>
           </a:solidFill>
           <a:ln/>
         </p:spPr>
@@ -4816,7 +4816,7 @@
         </p:nvSpPr>
         <p:spPr>
           <a:xfrm>
-            <a:off x="576072" y="1033272"/>
+            <a:off x="585216" y="1042416"/>
             <a:ext cx="8046720" cy="685800"/>
           </a:xfrm>
           <a:prstGeom prst="roundRect">
@@ -4825,7 +4825,7 @@
             </a:avLst>
           </a:prstGeom>
           <a:solidFill>
-            <a:srgbClr val="DDDDDD"/>
+            <a:srgbClr val="D9D4CB"/>
           </a:solidFill>
           <a:ln/>
         </p:spPr>
@@ -4847,7 +4847,7 @@
             </a:avLst>
           </a:prstGeom>
           <a:solidFill>
-            <a:srgbClr val="FFFFFF"/>
+            <a:srgbClr val="FFFEF9"/>
           </a:solidFill>
           <a:ln/>
         </p:spPr>
@@ -4861,13 +4861,13 @@
         <p:spPr>
           <a:xfrm>
             <a:off x="548640" y="1005840"/>
-            <a:ext cx="73152" cy="685800"/>
-          </a:xfrm>
-          <a:prstGeom prst="rect">
-            <a:avLst/>
-          </a:prstGeom>
-          <a:solidFill>
-            <a:srgbClr val="003087"/>
+            <a:ext cx="91440" cy="685800"/>
+          </a:xfrm>
+          <a:prstGeom prst="rect">
+            <a:avLst/>
+          </a:prstGeom>
+          <a:solidFill>
+            <a:srgbClr val="2D5A27"/>
           </a:solidFill>
           <a:ln/>
         </p:spPr>
@@ -4880,14 +4880,14 @@
         </p:nvSpPr>
         <p:spPr>
           <a:xfrm>
-            <a:off x="685800" y="1165860"/>
-            <a:ext cx="365760" cy="365760"/>
+            <a:off x="667512" y="1147572"/>
+            <a:ext cx="402336" cy="402336"/>
           </a:xfrm>
           <a:prstGeom prst="ellipse">
             <a:avLst/>
           </a:prstGeom>
           <a:solidFill>
-            <a:srgbClr val="003087"/>
+            <a:srgbClr val="2D5A27"/>
           </a:solidFill>
           <a:ln/>
         </p:spPr>
@@ -4900,8 +4900,8 @@
         </p:nvSpPr>
         <p:spPr>
           <a:xfrm>
-            <a:off x="685800" y="1165860"/>
-            <a:ext cx="365760" cy="365760"/>
+            <a:off x="667512" y="1147572"/>
+            <a:ext cx="402336" cy="402336"/>
           </a:xfrm>
           <a:prstGeom prst="rect">
             <a:avLst/>
@@ -4917,9 +4917,9 @@
               <a:buNone/>
             </a:pPr>
             <a:r>
-              <a:rPr lang="en-US" sz="1100" b="1" dirty="0">
+              <a:rPr lang="en-US" sz="1200" b="1" dirty="0">
                 <a:solidFill>
-                  <a:srgbClr val="FFFFFF"/>
+                  <a:srgbClr val="FFFEF9"/>
                 </a:solidFill>
                 <a:latin typeface="Calibri" pitchFamily="34" charset="0"/>
                 <a:ea typeface="Calibri" pitchFamily="34" charset="-122"/>
@@ -4927,7 +4927,7 @@
               </a:rPr>
               <a:t>1</a:t>
             </a:r>
-            <a:endParaRPr lang="en-US" sz="1100" dirty="0"/>
+            <a:endParaRPr lang="en-US" sz="1200" dirty="0"/>
           </a:p>
         </p:txBody>
       </p:sp>
@@ -4958,7 +4958,7 @@
             <a:r>
               <a:rPr lang="en-US" sz="1400" dirty="0">
                 <a:solidFill>
-                  <a:srgbClr val="333333"/>
+                  <a:srgbClr val="3D3D3D"/>
                 </a:solidFill>
                 <a:latin typeface="Calibri" pitchFamily="34" charset="0"/>
                 <a:ea typeface="Calibri" pitchFamily="34" charset="-122"/>
@@ -4978,7 +4978,7 @@
         </p:nvSpPr>
         <p:spPr>
           <a:xfrm>
-            <a:off x="576072" y="1856232"/>
+            <a:off x="585216" y="1865376"/>
             <a:ext cx="8046720" cy="685800"/>
           </a:xfrm>
           <a:prstGeom prst="roundRect">
@@ -4987,7 +4987,7 @@
             </a:avLst>
           </a:prstGeom>
           <a:solidFill>
-            <a:srgbClr val="DDDDDD"/>
+            <a:srgbClr val="D9D4CB"/>
           </a:solidFill>
           <a:ln/>
         </p:spPr>
@@ -5009,7 +5009,7 @@
             </a:avLst>
           </a:prstGeom>
           <a:solidFill>
-            <a:srgbClr val="FFFFFF"/>
+            <a:srgbClr val="FFFEF9"/>
           </a:solidFill>
           <a:ln/>
         </p:spPr>
@@ -5023,13 +5023,13 @@
         <p:spPr>
           <a:xfrm>
             <a:off x="548640" y="1828800"/>
-            <a:ext cx="73152" cy="685800"/>
-          </a:xfrm>
-          <a:prstGeom prst="rect">
-            <a:avLst/>
-          </a:prstGeom>
-          <a:solidFill>
-            <a:srgbClr val="003087"/>
+            <a:ext cx="91440" cy="685800"/>
+          </a:xfrm>
+          <a:prstGeom prst="rect">
+            <a:avLst/>
+          </a:prstGeom>
+          <a:solidFill>
+            <a:srgbClr val="2D5A27"/>
           </a:solidFill>
           <a:ln/>
         </p:spPr>
@@ -5042,14 +5042,14 @@
         </p:nvSpPr>
         <p:spPr>
           <a:xfrm>
-            <a:off x="685800" y="1988820"/>
-            <a:ext cx="365760" cy="365760"/>
+            <a:off x="667512" y="1970532"/>
+            <a:ext cx="402336" cy="402336"/>
           </a:xfrm>
           <a:prstGeom prst="ellipse">
             <a:avLst/>
           </a:prstGeom>
           <a:solidFill>
-            <a:srgbClr val="003087"/>
+            <a:srgbClr val="2D5A27"/>
           </a:solidFill>
           <a:ln/>
         </p:spPr>
@@ -5062,8 +5062,8 @@
         </p:nvSpPr>
         <p:spPr>
           <a:xfrm>
-            <a:off x="685800" y="1988820"/>
-            <a:ext cx="365760" cy="365760"/>
+            <a:off x="667512" y="1970532"/>
+            <a:ext cx="402336" cy="402336"/>
           </a:xfrm>
           <a:prstGeom prst="rect">
             <a:avLst/>
@@ -5079,9 +5079,9 @@
               <a:buNone/>
             </a:pPr>
             <a:r>
-              <a:rPr lang="en-US" sz="1100" b="1" dirty="0">
+              <a:rPr lang="en-US" sz="1200" b="1" dirty="0">
                 <a:solidFill>
-                  <a:srgbClr val="FFFFFF"/>
+                  <a:srgbClr val="FFFEF9"/>
                 </a:solidFill>
                 <a:latin typeface="Calibri" pitchFamily="34" charset="0"/>
                 <a:ea typeface="Calibri" pitchFamily="34" charset="-122"/>
@@ -5089,7 +5089,7 @@
               </a:rPr>
               <a:t>2</a:t>
             </a:r>
-            <a:endParaRPr lang="en-US" sz="1100" dirty="0"/>
+            <a:endParaRPr lang="en-US" sz="1200" dirty="0"/>
           </a:p>
         </p:txBody>
       </p:sp>
@@ -5120,7 +5120,7 @@
             <a:r>
               <a:rPr lang="en-US" sz="1400" dirty="0">
                 <a:solidFill>
-                  <a:srgbClr val="333333"/>
+                  <a:srgbClr val="3D3D3D"/>
                 </a:solidFill>
                 <a:latin typeface="Calibri" pitchFamily="34" charset="0"/>
                 <a:ea typeface="Calibri" pitchFamily="34" charset="-122"/>
@@ -5140,7 +5140,7 @@
         </p:nvSpPr>
         <p:spPr>
           <a:xfrm>
-            <a:off x="576072" y="2679192"/>
+            <a:off x="585216" y="2688336"/>
             <a:ext cx="8046720" cy="685800"/>
           </a:xfrm>
           <a:prstGeom prst="roundRect">
@@ -5149,7 +5149,7 @@
             </a:avLst>
           </a:prstGeom>
           <a:solidFill>
-            <a:srgbClr val="DDDDDD"/>
+            <a:srgbClr val="D9D4CB"/>
           </a:solidFill>
           <a:ln/>
         </p:spPr>
@@ -5171,7 +5171,7 @@
             </a:avLst>
           </a:prstGeom>
           <a:solidFill>
-            <a:srgbClr val="FFFFFF"/>
+            <a:srgbClr val="FFFEF9"/>
           </a:solidFill>
           <a:ln/>
         </p:spPr>
@@ -5185,13 +5185,13 @@
         <p:spPr>
           <a:xfrm>
             <a:off x="548640" y="2651760"/>
-            <a:ext cx="73152" cy="685800"/>
-          </a:xfrm>
-          <a:prstGeom prst="rect">
-            <a:avLst/>
-          </a:prstGeom>
-          <a:solidFill>
-            <a:srgbClr val="003087"/>
+            <a:ext cx="91440" cy="685800"/>
+          </a:xfrm>
+          <a:prstGeom prst="rect">
+            <a:avLst/>
+          </a:prstGeom>
+          <a:solidFill>
+            <a:srgbClr val="2D5A27"/>
           </a:solidFill>
           <a:ln/>
         </p:spPr>
@@ -5204,14 +5204,14 @@
         </p:nvSpPr>
         <p:spPr>
           <a:xfrm>
-            <a:off x="685800" y="2811780"/>
-            <a:ext cx="365760" cy="365760"/>
+            <a:off x="667512" y="2793492"/>
+            <a:ext cx="402336" cy="402336"/>
           </a:xfrm>
           <a:prstGeom prst="ellipse">
             <a:avLst/>
           </a:prstGeom>
           <a:solidFill>
-            <a:srgbClr val="003087"/>
+            <a:srgbClr val="2D5A27"/>
           </a:solidFill>
           <a:ln/>
         </p:spPr>
@@ -5224,8 +5224,8 @@
         </p:nvSpPr>
         <p:spPr>
           <a:xfrm>
-            <a:off x="685800" y="2811780"/>
-            <a:ext cx="365760" cy="365760"/>
+            <a:off x="667512" y="2793492"/>
+            <a:ext cx="402336" cy="402336"/>
           </a:xfrm>
           <a:prstGeom prst="rect">
             <a:avLst/>
@@ -5241,9 +5241,9 @@
               <a:buNone/>
             </a:pPr>
             <a:r>
-              <a:rPr lang="en-US" sz="1100" b="1" dirty="0">
+              <a:rPr lang="en-US" sz="1200" b="1" dirty="0">
                 <a:solidFill>
-                  <a:srgbClr val="FFFFFF"/>
+                  <a:srgbClr val="FFFEF9"/>
                 </a:solidFill>
                 <a:latin typeface="Calibri" pitchFamily="34" charset="0"/>
                 <a:ea typeface="Calibri" pitchFamily="34" charset="-122"/>
@@ -5251,7 +5251,7 @@
               </a:rPr>
               <a:t>3</a:t>
             </a:r>
-            <a:endParaRPr lang="en-US" sz="1100" dirty="0"/>
+            <a:endParaRPr lang="en-US" sz="1200" dirty="0"/>
           </a:p>
         </p:txBody>
       </p:sp>
@@ -5282,7 +5282,7 @@
             <a:r>
               <a:rPr lang="en-US" sz="1400" dirty="0">
                 <a:solidFill>
-                  <a:srgbClr val="333333"/>
+                  <a:srgbClr val="3D3D3D"/>
                 </a:solidFill>
                 <a:latin typeface="Calibri" pitchFamily="34" charset="0"/>
                 <a:ea typeface="Calibri" pitchFamily="34" charset="-122"/>
@@ -5302,7 +5302,7 @@
         </p:nvSpPr>
         <p:spPr>
           <a:xfrm>
-            <a:off x="576072" y="3502152"/>
+            <a:off x="585216" y="3511296"/>
             <a:ext cx="8046720" cy="685800"/>
           </a:xfrm>
           <a:prstGeom prst="roundRect">
@@ -5311,7 +5311,7 @@
             </a:avLst>
           </a:prstGeom>
           <a:solidFill>
-            <a:srgbClr val="DDDDDD"/>
+            <a:srgbClr val="D9D4CB"/>
           </a:solidFill>
           <a:ln/>
         </p:spPr>
@@ -5333,7 +5333,7 @@
             </a:avLst>
           </a:prstGeom>
           <a:solidFill>
-            <a:srgbClr val="FFFFFF"/>
+            <a:srgbClr val="FFFEF9"/>
           </a:solidFill>
           <a:ln/>
         </p:spPr>
@@ -5347,13 +5347,13 @@
         <p:spPr>
           <a:xfrm>
             <a:off x="548640" y="3474720"/>
-            <a:ext cx="73152" cy="685800"/>
-          </a:xfrm>
-          <a:prstGeom prst="rect">
-            <a:avLst/>
-          </a:prstGeom>
-          <a:solidFill>
-            <a:srgbClr val="003087"/>
+            <a:ext cx="91440" cy="685800"/>
+          </a:xfrm>
+          <a:prstGeom prst="rect">
+            <a:avLst/>
+          </a:prstGeom>
+          <a:solidFill>
+            <a:srgbClr val="2D5A27"/>
           </a:solidFill>
           <a:ln/>
         </p:spPr>
@@ -5366,14 +5366,14 @@
         </p:nvSpPr>
         <p:spPr>
           <a:xfrm>
-            <a:off x="685800" y="3634740"/>
-            <a:ext cx="365760" cy="365760"/>
+            <a:off x="667512" y="3616452"/>
+            <a:ext cx="402336" cy="402336"/>
           </a:xfrm>
           <a:prstGeom prst="ellipse">
             <a:avLst/>
           </a:prstGeom>
           <a:solidFill>
-            <a:srgbClr val="003087"/>
+            <a:srgbClr val="2D5A27"/>
           </a:solidFill>
           <a:ln/>
         </p:spPr>
@@ -5386,8 +5386,8 @@
         </p:nvSpPr>
         <p:spPr>
           <a:xfrm>
-            <a:off x="685800" y="3634740"/>
-            <a:ext cx="365760" cy="365760"/>
+            <a:off x="667512" y="3616452"/>
+            <a:ext cx="402336" cy="402336"/>
           </a:xfrm>
           <a:prstGeom prst="rect">
             <a:avLst/>
@@ -5403,9 +5403,9 @@
               <a:buNone/>
             </a:pPr>
             <a:r>
-              <a:rPr lang="en-US" sz="1100" b="1" dirty="0">
+              <a:rPr lang="en-US" sz="1200" b="1" dirty="0">
                 <a:solidFill>
-                  <a:srgbClr val="FFFFFF"/>
+                  <a:srgbClr val="FFFEF9"/>
                 </a:solidFill>
                 <a:latin typeface="Calibri" pitchFamily="34" charset="0"/>
                 <a:ea typeface="Calibri" pitchFamily="34" charset="-122"/>
@@ -5413,7 +5413,7 @@
               </a:rPr>
               <a:t>4</a:t>
             </a:r>
-            <a:endParaRPr lang="en-US" sz="1100" dirty="0"/>
+            <a:endParaRPr lang="en-US" sz="1200" dirty="0"/>
           </a:p>
         </p:txBody>
       </p:sp>
@@ -5444,7 +5444,7 @@
             <a:r>
               <a:rPr lang="en-US" sz="1400" dirty="0">
                 <a:solidFill>
-                  <a:srgbClr val="333333"/>
+                  <a:srgbClr val="3D3D3D"/>
                 </a:solidFill>
                 <a:latin typeface="Calibri" pitchFamily="34" charset="0"/>
                 <a:ea typeface="Calibri" pitchFamily="34" charset="-122"/>
@@ -5473,7 +5473,7 @@
             </a:avLst>
           </a:prstGeom>
           <a:solidFill>
-            <a:srgbClr val="003087"/>
+            <a:srgbClr val="2D5A27"/>
           </a:solidFill>
           <a:ln/>
         </p:spPr>
@@ -5505,7 +5505,7 @@
             <a:r>
               <a:rPr lang="en-US" sz="1300" i="1" dirty="0">
                 <a:solidFill>
-                  <a:srgbClr val="FFFFFF"/>
+                  <a:srgbClr val="FFFEF9"/>
                 </a:solidFill>
                 <a:latin typeface="Calibri" pitchFamily="34" charset="0"/>
                 <a:ea typeface="Calibri" pitchFamily="34" charset="-122"/>
@@ -5531,7 +5531,7 @@
     <p:bg>
       <p:bgPr>
         <a:solidFill>
-          <a:srgbClr val="F5F5F5"/>
+          <a:srgbClr val="FDF8F3"/>
         </a:solidFill>
       </p:bgPr>
     </p:bg>
@@ -5576,7 +5576,7 @@
             <a:r>
               <a:rPr lang="en-US" sz="2600" b="1" dirty="0">
                 <a:solidFill>
-                  <a:srgbClr val="003087"/>
+                  <a:srgbClr val="2D5A27"/>
                 </a:solidFill>
                 <a:latin typeface="Georgia" pitchFamily="34" charset="0"/>
                 <a:ea typeface="Georgia" pitchFamily="34" charset="-122"/>
@@ -5603,7 +5603,7 @@
             <a:avLst/>
           </a:prstGeom>
           <a:solidFill>
-            <a:srgbClr val="E67E22"/>
+            <a:srgbClr val="D4A574"/>
           </a:solidFill>
           <a:ln/>
         </p:spPr>
@@ -5616,7 +5616,7 @@
         </p:nvSpPr>
         <p:spPr>
           <a:xfrm>
-            <a:off x="576072" y="1033272"/>
+            <a:off x="585216" y="1042416"/>
             <a:ext cx="8046720" cy="685800"/>
           </a:xfrm>
           <a:prstGeom prst="roundRect">
@@ -5625,7 +5625,7 @@
             </a:avLst>
           </a:prstGeom>
           <a:solidFill>
-            <a:srgbClr val="DDDDDD"/>
+            <a:srgbClr val="D9D4CB"/>
           </a:solidFill>
           <a:ln/>
         </p:spPr>
@@ -5647,7 +5647,7 @@
             </a:avLst>
           </a:prstGeom>
           <a:solidFill>
-            <a:srgbClr val="FFFFFF"/>
+            <a:srgbClr val="FFFEF9"/>
           </a:solidFill>
           <a:ln/>
         </p:spPr>
@@ -5661,13 +5661,13 @@
         <p:spPr>
           <a:xfrm>
             <a:off x="548640" y="1005840"/>
-            <a:ext cx="73152" cy="685800"/>
-          </a:xfrm>
-          <a:prstGeom prst="rect">
-            <a:avLst/>
-          </a:prstGeom>
-          <a:solidFill>
-            <a:srgbClr val="003087"/>
+            <a:ext cx="91440" cy="685800"/>
+          </a:xfrm>
+          <a:prstGeom prst="rect">
+            <a:avLst/>
+          </a:prstGeom>
+          <a:solidFill>
+            <a:srgbClr val="2D5A27"/>
           </a:solidFill>
           <a:ln/>
         </p:spPr>
@@ -5680,14 +5680,14 @@
         </p:nvSpPr>
         <p:spPr>
           <a:xfrm>
-            <a:off x="685800" y="1165860"/>
-            <a:ext cx="365760" cy="365760"/>
+            <a:off x="667512" y="1147572"/>
+            <a:ext cx="402336" cy="402336"/>
           </a:xfrm>
           <a:prstGeom prst="ellipse">
             <a:avLst/>
           </a:prstGeom>
           <a:solidFill>
-            <a:srgbClr val="003087"/>
+            <a:srgbClr val="2D5A27"/>
           </a:solidFill>
           <a:ln/>
         </p:spPr>
@@ -5700,8 +5700,8 @@
         </p:nvSpPr>
         <p:spPr>
           <a:xfrm>
-            <a:off x="685800" y="1165860"/>
-            <a:ext cx="365760" cy="365760"/>
+            <a:off x="667512" y="1147572"/>
+            <a:ext cx="402336" cy="402336"/>
           </a:xfrm>
           <a:prstGeom prst="rect">
             <a:avLst/>
@@ -5717,9 +5717,9 @@
               <a:buNone/>
             </a:pPr>
             <a:r>
-              <a:rPr lang="en-US" sz="1100" b="1" dirty="0">
+              <a:rPr lang="en-US" sz="1200" b="1" dirty="0">
                 <a:solidFill>
-                  <a:srgbClr val="FFFFFF"/>
+                  <a:srgbClr val="FFFEF9"/>
                 </a:solidFill>
                 <a:latin typeface="Calibri" pitchFamily="34" charset="0"/>
                 <a:ea typeface="Calibri" pitchFamily="34" charset="-122"/>
@@ -5727,7 +5727,7 @@
               </a:rPr>
               <a:t>1</a:t>
             </a:r>
-            <a:endParaRPr lang="en-US" sz="1100" dirty="0"/>
+            <a:endParaRPr lang="en-US" sz="1200" dirty="0"/>
           </a:p>
         </p:txBody>
       </p:sp>
@@ -5758,7 +5758,7 @@
             <a:r>
               <a:rPr lang="en-US" sz="1400" dirty="0">
                 <a:solidFill>
-                  <a:srgbClr val="333333"/>
+                  <a:srgbClr val="3D3D3D"/>
                 </a:solidFill>
                 <a:latin typeface="Calibri" pitchFamily="34" charset="0"/>
                 <a:ea typeface="Calibri" pitchFamily="34" charset="-122"/>
@@ -5778,7 +5778,7 @@
         </p:nvSpPr>
         <p:spPr>
           <a:xfrm>
-            <a:off x="576072" y="1856232"/>
+            <a:off x="585216" y="1865376"/>
             <a:ext cx="8046720" cy="685800"/>
           </a:xfrm>
           <a:prstGeom prst="roundRect">
@@ -5787,7 +5787,7 @@
             </a:avLst>
           </a:prstGeom>
           <a:solidFill>
-            <a:srgbClr val="DDDDDD"/>
+            <a:srgbClr val="D9D4CB"/>
           </a:solidFill>
           <a:ln/>
         </p:spPr>
@@ -5809,7 +5809,7 @@
             </a:avLst>
           </a:prstGeom>
           <a:solidFill>
-            <a:srgbClr val="FFFFFF"/>
+            <a:srgbClr val="FFFEF9"/>
           </a:solidFill>
           <a:ln/>
         </p:spPr>
@@ -5823,13 +5823,13 @@
         <p:spPr>
           <a:xfrm>
             <a:off x="548640" y="1828800"/>
-            <a:ext cx="73152" cy="685800"/>
-          </a:xfrm>
-          <a:prstGeom prst="rect">
-            <a:avLst/>
-          </a:prstGeom>
-          <a:solidFill>
-            <a:srgbClr val="003087"/>
+            <a:ext cx="91440" cy="685800"/>
+          </a:xfrm>
+          <a:prstGeom prst="rect">
+            <a:avLst/>
+          </a:prstGeom>
+          <a:solidFill>
+            <a:srgbClr val="2D5A27"/>
           </a:solidFill>
           <a:ln/>
         </p:spPr>
@@ -5842,14 +5842,14 @@
         </p:nvSpPr>
         <p:spPr>
           <a:xfrm>
-            <a:off x="685800" y="1988820"/>
-            <a:ext cx="365760" cy="365760"/>
+            <a:off x="667512" y="1970532"/>
+            <a:ext cx="402336" cy="402336"/>
           </a:xfrm>
           <a:prstGeom prst="ellipse">
             <a:avLst/>
           </a:prstGeom>
           <a:solidFill>
-            <a:srgbClr val="003087"/>
+            <a:srgbClr val="2D5A27"/>
           </a:solidFill>
           <a:ln/>
         </p:spPr>
@@ -5862,8 +5862,8 @@
         </p:nvSpPr>
         <p:spPr>
           <a:xfrm>
-            <a:off x="685800" y="1988820"/>
-            <a:ext cx="365760" cy="365760"/>
+            <a:off x="667512" y="1970532"/>
+            <a:ext cx="402336" cy="402336"/>
           </a:xfrm>
           <a:prstGeom prst="rect">
             <a:avLst/>
@@ -5879,9 +5879,9 @@
               <a:buNone/>
             </a:pPr>
             <a:r>
-              <a:rPr lang="en-US" sz="1100" b="1" dirty="0">
+              <a:rPr lang="en-US" sz="1200" b="1" dirty="0">
                 <a:solidFill>
-                  <a:srgbClr val="FFFFFF"/>
+                  <a:srgbClr val="FFFEF9"/>
                 </a:solidFill>
                 <a:latin typeface="Calibri" pitchFamily="34" charset="0"/>
                 <a:ea typeface="Calibri" pitchFamily="34" charset="-122"/>
@@ -5889,7 +5889,7 @@
               </a:rPr>
               <a:t>2</a:t>
             </a:r>
-            <a:endParaRPr lang="en-US" sz="1100" dirty="0"/>
+            <a:endParaRPr lang="en-US" sz="1200" dirty="0"/>
           </a:p>
         </p:txBody>
       </p:sp>
@@ -5920,7 +5920,7 @@
             <a:r>
               <a:rPr lang="en-US" sz="1400" dirty="0">
                 <a:solidFill>
-                  <a:srgbClr val="333333"/>
+                  <a:srgbClr val="3D3D3D"/>
                 </a:solidFill>
                 <a:latin typeface="Calibri" pitchFamily="34" charset="0"/>
                 <a:ea typeface="Calibri" pitchFamily="34" charset="-122"/>
@@ -5940,7 +5940,7 @@
         </p:nvSpPr>
         <p:spPr>
           <a:xfrm>
-            <a:off x="576072" y="2679192"/>
+            <a:off x="585216" y="2688336"/>
             <a:ext cx="8046720" cy="685800"/>
           </a:xfrm>
           <a:prstGeom prst="roundRect">
@@ -5949,7 +5949,7 @@
             </a:avLst>
           </a:prstGeom>
           <a:solidFill>
-            <a:srgbClr val="DDDDDD"/>
+            <a:srgbClr val="D9D4CB"/>
           </a:solidFill>
           <a:ln/>
         </p:spPr>
@@ -5971,7 +5971,7 @@
             </a:avLst>
           </a:prstGeom>
           <a:solidFill>
-            <a:srgbClr val="FFFFFF"/>
+            <a:srgbClr val="FFFEF9"/>
           </a:solidFill>
           <a:ln/>
         </p:spPr>
@@ -5985,13 +5985,13 @@
         <p:spPr>
           <a:xfrm>
             <a:off x="548640" y="2651760"/>
-            <a:ext cx="73152" cy="685800"/>
-          </a:xfrm>
-          <a:prstGeom prst="rect">
-            <a:avLst/>
-          </a:prstGeom>
-          <a:solidFill>
-            <a:srgbClr val="003087"/>
+            <a:ext cx="91440" cy="685800"/>
+          </a:xfrm>
+          <a:prstGeom prst="rect">
+            <a:avLst/>
+          </a:prstGeom>
+          <a:solidFill>
+            <a:srgbClr val="2D5A27"/>
           </a:solidFill>
           <a:ln/>
         </p:spPr>
@@ -6004,14 +6004,14 @@
         </p:nvSpPr>
         <p:spPr>
           <a:xfrm>
-            <a:off x="685800" y="2811780"/>
-            <a:ext cx="365760" cy="365760"/>
+            <a:off x="667512" y="2793492"/>
+            <a:ext cx="402336" cy="402336"/>
           </a:xfrm>
           <a:prstGeom prst="ellipse">
             <a:avLst/>
           </a:prstGeom>
           <a:solidFill>
-            <a:srgbClr val="003087"/>
+            <a:srgbClr val="2D5A27"/>
           </a:solidFill>
           <a:ln/>
         </p:spPr>
@@ -6024,8 +6024,8 @@
         </p:nvSpPr>
         <p:spPr>
           <a:xfrm>
-            <a:off x="685800" y="2811780"/>
-            <a:ext cx="365760" cy="365760"/>
+            <a:off x="667512" y="2793492"/>
+            <a:ext cx="402336" cy="402336"/>
           </a:xfrm>
           <a:prstGeom prst="rect">
             <a:avLst/>
@@ -6041,9 +6041,9 @@
               <a:buNone/>
             </a:pPr>
             <a:r>
-              <a:rPr lang="en-US" sz="1100" b="1" dirty="0">
+              <a:rPr lang="en-US" sz="1200" b="1" dirty="0">
                 <a:solidFill>
-                  <a:srgbClr val="FFFFFF"/>
+                  <a:srgbClr val="FFFEF9"/>
                 </a:solidFill>
                 <a:latin typeface="Calibri" pitchFamily="34" charset="0"/>
                 <a:ea typeface="Calibri" pitchFamily="34" charset="-122"/>
@@ -6051,7 +6051,7 @@
               </a:rPr>
               <a:t>3</a:t>
             </a:r>
-            <a:endParaRPr lang="en-US" sz="1100" dirty="0"/>
+            <a:endParaRPr lang="en-US" sz="1200" dirty="0"/>
           </a:p>
         </p:txBody>
       </p:sp>
@@ -6082,7 +6082,7 @@
             <a:r>
               <a:rPr lang="en-US" sz="1400" dirty="0">
                 <a:solidFill>
-                  <a:srgbClr val="333333"/>
+                  <a:srgbClr val="3D3D3D"/>
                 </a:solidFill>
                 <a:latin typeface="Calibri" pitchFamily="34" charset="0"/>
                 <a:ea typeface="Calibri" pitchFamily="34" charset="-122"/>
@@ -6102,7 +6102,7 @@
         </p:nvSpPr>
         <p:spPr>
           <a:xfrm>
-            <a:off x="576072" y="3502152"/>
+            <a:off x="585216" y="3511296"/>
             <a:ext cx="8046720" cy="685800"/>
           </a:xfrm>
           <a:prstGeom prst="roundRect">
@@ -6111,7 +6111,7 @@
             </a:avLst>
           </a:prstGeom>
           <a:solidFill>
-            <a:srgbClr val="DDDDDD"/>
+            <a:srgbClr val="D9D4CB"/>
           </a:solidFill>
           <a:ln/>
         </p:spPr>
@@ -6133,7 +6133,7 @@
             </a:avLst>
           </a:prstGeom>
           <a:solidFill>
-            <a:srgbClr val="FFFFFF"/>
+            <a:srgbClr val="FFFEF9"/>
           </a:solidFill>
           <a:ln/>
         </p:spPr>
@@ -6147,13 +6147,13 @@
         <p:spPr>
           <a:xfrm>
             <a:off x="548640" y="3474720"/>
-            <a:ext cx="73152" cy="685800"/>
-          </a:xfrm>
-          <a:prstGeom prst="rect">
-            <a:avLst/>
-          </a:prstGeom>
-          <a:solidFill>
-            <a:srgbClr val="003087"/>
+            <a:ext cx="91440" cy="685800"/>
+          </a:xfrm>
+          <a:prstGeom prst="rect">
+            <a:avLst/>
+          </a:prstGeom>
+          <a:solidFill>
+            <a:srgbClr val="2D5A27"/>
           </a:solidFill>
           <a:ln/>
         </p:spPr>
@@ -6166,14 +6166,14 @@
         </p:nvSpPr>
         <p:spPr>
           <a:xfrm>
-            <a:off x="685800" y="3634740"/>
-            <a:ext cx="365760" cy="365760"/>
+            <a:off x="667512" y="3616452"/>
+            <a:ext cx="402336" cy="402336"/>
           </a:xfrm>
           <a:prstGeom prst="ellipse">
             <a:avLst/>
           </a:prstGeom>
           <a:solidFill>
-            <a:srgbClr val="003087"/>
+            <a:srgbClr val="2D5A27"/>
           </a:solidFill>
           <a:ln/>
         </p:spPr>
@@ -6186,8 +6186,8 @@
         </p:nvSpPr>
         <p:spPr>
           <a:xfrm>
-            <a:off x="685800" y="3634740"/>
-            <a:ext cx="365760" cy="365760"/>
+            <a:off x="667512" y="3616452"/>
+            <a:ext cx="402336" cy="402336"/>
           </a:xfrm>
           <a:prstGeom prst="rect">
             <a:avLst/>
@@ -6203,9 +6203,9 @@
               <a:buNone/>
             </a:pPr>
             <a:r>
-              <a:rPr lang="en-US" sz="1100" b="1" dirty="0">
+              <a:rPr lang="en-US" sz="1200" b="1" dirty="0">
                 <a:solidFill>
-                  <a:srgbClr val="FFFFFF"/>
+                  <a:srgbClr val="FFFEF9"/>
                 </a:solidFill>
                 <a:latin typeface="Calibri" pitchFamily="34" charset="0"/>
                 <a:ea typeface="Calibri" pitchFamily="34" charset="-122"/>
@@ -6213,7 +6213,7 @@
               </a:rPr>
               <a:t>4</a:t>
             </a:r>
-            <a:endParaRPr lang="en-US" sz="1100" dirty="0"/>
+            <a:endParaRPr lang="en-US" sz="1200" dirty="0"/>
           </a:p>
         </p:txBody>
       </p:sp>
@@ -6244,7 +6244,7 @@
             <a:r>
               <a:rPr lang="en-US" sz="1400" dirty="0">
                 <a:solidFill>
-                  <a:srgbClr val="333333"/>
+                  <a:srgbClr val="3D3D3D"/>
                 </a:solidFill>
                 <a:latin typeface="Calibri" pitchFamily="34" charset="0"/>
                 <a:ea typeface="Calibri" pitchFamily="34" charset="-122"/>
@@ -6273,7 +6273,7 @@
             </a:avLst>
           </a:prstGeom>
           <a:solidFill>
-            <a:srgbClr val="003087"/>
+            <a:srgbClr val="2D5A27"/>
           </a:solidFill>
           <a:ln/>
         </p:spPr>
@@ -6305,7 +6305,7 @@
             <a:r>
               <a:rPr lang="en-US" sz="1300" i="1" dirty="0">
                 <a:solidFill>
-                  <a:srgbClr val="FFFFFF"/>
+                  <a:srgbClr val="FFFEF9"/>
                 </a:solidFill>
                 <a:latin typeface="Calibri" pitchFamily="34" charset="0"/>
                 <a:ea typeface="Calibri" pitchFamily="34" charset="-122"/>
@@ -6334,7 +6334,7 @@
             </a:avLst>
           </a:prstGeom>
           <a:solidFill>
-            <a:srgbClr val="003087"/>
+            <a:srgbClr val="2D5A27"/>
           </a:solidFill>
           <a:ln/>
         </p:spPr>
@@ -6366,7 +6366,7 @@
             <a:r>
               <a:rPr lang="en-US" sz="1300" i="1" dirty="0">
                 <a:solidFill>
-                  <a:srgbClr val="FFFFFF"/>
+                  <a:srgbClr val="FFFEF9"/>
                 </a:solidFill>
                 <a:latin typeface="Calibri" pitchFamily="34" charset="0"/>
                 <a:ea typeface="Calibri" pitchFamily="34" charset="-122"/>
@@ -6392,7 +6392,7 @@
     <p:bg>
       <p:bgPr>
         <a:solidFill>
-          <a:srgbClr val="F5F5F5"/>
+          <a:srgbClr val="FDF8F3"/>
         </a:solidFill>
       </p:bgPr>
     </p:bg>
@@ -6437,7 +6437,7 @@
             <a:r>
               <a:rPr lang="en-US" sz="2600" b="1" dirty="0">
                 <a:solidFill>
-                  <a:srgbClr val="003087"/>
+                  <a:srgbClr val="2D5A27"/>
                 </a:solidFill>
                 <a:latin typeface="Georgia" pitchFamily="34" charset="0"/>
                 <a:ea typeface="Georgia" pitchFamily="34" charset="-122"/>
@@ -6464,7 +6464,7 @@
             <a:avLst/>
           </a:prstGeom>
           <a:solidFill>
-            <a:srgbClr val="E67E22"/>
+            <a:srgbClr val="D4A574"/>
           </a:solidFill>
           <a:ln/>
         </p:spPr>

</xml_diff>